<commit_message>
feat(project-13): finalize 100% complete implementation, models, tests, docs, PPT, and video demonstration for PROJECT-013
</commit_message>
<xml_diff>
--- a/project_13_crime_prediction_forecasting/presentations/project_presentation.pptx
+++ b/project_13_crime_prediction_forecasting/presentations/project_presentation.pptx
@@ -13,6 +13,13 @@
     <p:sldId id="261" r:id="rId12"/>
     <p:sldId id="262" r:id="rId13"/>
     <p:sldId id="263" r:id="rId14"/>
+    <p:sldId id="264" r:id="rId15"/>
+    <p:sldId id="265" r:id="rId16"/>
+    <p:sldId id="266" r:id="rId17"/>
+    <p:sldId id="267" r:id="rId18"/>
+    <p:sldId id="268" r:id="rId19"/>
+    <p:sldId id="269" r:id="rId20"/>
+    <p:sldId id="270" r:id="rId21"/>
   </p:sldIdLst>
   <p:sldSz cx="12191695" cy="6858000" type="screen4x3"/>
   <p:notesSz cx="6858000" cy="9144000"/>
@@ -3110,7 +3117,7 @@
             <a:avLst/>
           </a:prstGeom>
           <a:solidFill>
-            <a:srgbClr val="0F172A"/>
+            <a:srgbClr val="0A0F1E"/>
           </a:solidFill>
           <a:ln>
             <a:noFill/>
@@ -3146,8 +3153,8 @@
         </p:nvSpPr>
         <p:spPr>
           <a:xfrm>
-            <a:off x="1097280" y="1645920"/>
-            <a:ext cx="10058400" cy="3474720"/>
+            <a:off x="914400" y="1645920"/>
+            <a:ext cx="10362895" cy="3474720"/>
           </a:xfrm>
           <a:prstGeom prst="rect">
             <a:avLst/>
@@ -3161,44 +3168,1647 @@
           <a:lstStyle/>
           <a:p>
             <a:pPr>
-              <a:defRPr sz="1400" b="1">
-                <a:solidFill>
-                  <a:srgbClr val="38BDF8"/>
-                </a:solidFill>
-              </a:defRPr>
-            </a:pPr>
-            <a:r>
-              <a:t>PROJECT 13 OF 55  •  RESEARCH &amp; IMPLEMENTATION DECK</a:t>
-            </a:r>
-          </a:p>
-          <a:p>
-            <a:pPr>
-              <a:spcBef>
-                <a:spcPts val="1400"/>
-              </a:spcBef>
-              <a:defRPr sz="3200" b="1">
-                <a:solidFill>
-                  <a:srgbClr val="FFFFFF"/>
-                </a:solidFill>
-              </a:defRPr>
-            </a:pPr>
-            <a:r>
-              <a:t>EMPIRICAL ANALYSIS FOR CRIME PREDICTION AND FORECASTING USING MACHINE LEARNING AND DEEP LEARNING TECHNIQUES</a:t>
-            </a:r>
-          </a:p>
-          <a:p>
-            <a:pPr>
-              <a:spcBef>
-                <a:spcPts val="1200"/>
-              </a:spcBef>
-              <a:defRPr sz="1600">
-                <a:solidFill>
-                  <a:srgbClr val="CBD5E1"/>
-                </a:solidFill>
-              </a:defRPr>
-            </a:pPr>
-            <a:r>
-              <a:t>Enterprise-Grade AI Architecture, Machine Learning Pipeline &amp; Deployment Framework</a:t>
+              <a:defRPr sz="1300" b="1">
+                <a:solidFill>
+                  <a:srgbClr val="3B82F6"/>
+                </a:solidFill>
+              </a:defRPr>
+            </a:pPr>
+            <a:r>
+              <a:t>PROJECT 13 OF 55 • SMART CITY CRIME ANALYTICS &amp; DEEP LEARNING</a:t>
+            </a:r>
+          </a:p>
+          <a:p>
+            <a:pPr>
+              <a:defRPr sz="3400" b="1">
+                <a:solidFill>
+                  <a:srgbClr val="F8FAFC"/>
+                </a:solidFill>
+              </a:defRPr>
+            </a:pPr>
+            <a:r>
+              <a:t>Empirical Analysis for Crime Prediction and Forecasting</a:t>
+            </a:r>
+            <a:br/>
+            <a:r>
+              <a:t>Using Machine Learning &amp; Deep Learning Techniques</a:t>
+            </a:r>
+          </a:p>
+          <a:p>
+            <a:br/>
+            <a:pPr>
+              <a:defRPr sz="1500">
+                <a:solidFill>
+                  <a:srgbClr val="94A3B8"/>
+                </a:solidFill>
+              </a:defRPr>
+            </a:pPr>
+            <a:r>
+              <a:t>A high-throughput spatio-temporal public safety platform combining PyTorch Deep Neural Networks, Random Forest multi-class classification, 24-hour crime spike curves, and relational SQLite patrol dispatching.</a:t>
+            </a:r>
+          </a:p>
+        </p:txBody>
+      </p:sp>
+    </p:spTree>
+  </p:cSld>
+  <p:clrMapOvr>
+    <a:masterClrMapping/>
+  </p:clrMapOvr>
+</p:sld>
+</file>
+
+<file path=ppt/slides/slide10.xml><?xml version="1.0" encoding="utf-8"?>
+<p:sld xmlns:a="http://schemas.openxmlformats.org/drawingml/2006/main" xmlns:p="http://schemas.openxmlformats.org/presentationml/2006/main" xmlns:r="http://schemas.openxmlformats.org/officeDocument/2006/relationships">
+  <p:cSld>
+    <p:spTree>
+      <p:nvGrpSpPr>
+        <p:cNvPr id="1" name=""/>
+        <p:cNvGrpSpPr/>
+        <p:nvPr/>
+      </p:nvGrpSpPr>
+      <p:grpSpPr/>
+      <p:sp>
+        <p:nvSpPr>
+          <p:cNvPr id="2" name="Rectangle 1"/>
+          <p:cNvSpPr/>
+          <p:nvPr/>
+        </p:nvSpPr>
+        <p:spPr>
+          <a:xfrm>
+            <a:off x="0" y="0"/>
+            <a:ext cx="12191695" cy="6858000"/>
+          </a:xfrm>
+          <a:prstGeom prst="rect">
+            <a:avLst/>
+          </a:prstGeom>
+          <a:solidFill>
+            <a:srgbClr val="0A0F1E"/>
+          </a:solidFill>
+          <a:ln>
+            <a:noFill/>
+          </a:ln>
+        </p:spPr>
+        <p:style>
+          <a:lnRef idx="1">
+            <a:schemeClr val="accent1"/>
+          </a:lnRef>
+          <a:fillRef idx="3">
+            <a:schemeClr val="accent1"/>
+          </a:fillRef>
+          <a:effectRef idx="2">
+            <a:schemeClr val="accent1"/>
+          </a:effectRef>
+          <a:fontRef idx="minor">
+            <a:schemeClr val="lt1"/>
+          </a:fontRef>
+        </p:style>
+        <p:txBody>
+          <a:bodyPr rtlCol="0" anchor="ctr"/>
+          <a:lstStyle/>
+          <a:p>
+            <a:pPr algn="ctr"/>
+          </a:p>
+        </p:txBody>
+      </p:sp>
+      <p:sp>
+        <p:nvSpPr>
+          <p:cNvPr id="3" name="TextBox 2"/>
+          <p:cNvSpPr txBox="1"/>
+          <p:nvPr/>
+        </p:nvSpPr>
+        <p:spPr>
+          <a:xfrm>
+            <a:off x="731520" y="365760"/>
+            <a:ext cx="10728655" cy="1005840"/>
+          </a:xfrm>
+          <a:prstGeom prst="rect">
+            <a:avLst/>
+          </a:prstGeom>
+          <a:noFill/>
+        </p:spPr>
+        <p:txBody>
+          <a:bodyPr wrap="square">
+            <a:spAutoFit/>
+          </a:bodyPr>
+          <a:lstStyle/>
+          <a:p>
+            <a:pPr>
+              <a:defRPr sz="1100" b="1">
+                <a:solidFill>
+                  <a:srgbClr val="3B82F6"/>
+                </a:solidFill>
+              </a:defRPr>
+            </a:pPr>
+            <a:r>
+              <a:t>PUBLIC SAFETY AI &amp; PREDICTIVE LAW ENFORCEMENT</a:t>
+            </a:r>
+          </a:p>
+          <a:p>
+            <a:pPr>
+              <a:defRPr sz="2200" b="1">
+                <a:solidFill>
+                  <a:srgbClr val="F8FAFC"/>
+                </a:solidFill>
+              </a:defRPr>
+            </a:pPr>
+            <a:r>
+              <a:t>Low-Threat Suburban Sector Baseline Clearance</a:t>
+            </a:r>
+          </a:p>
+        </p:txBody>
+      </p:sp>
+      <p:pic>
+        <p:nvPicPr>
+          <p:cNvPr id="4" name="Picture 3" descr="04_low_threat_suburban_prediction.png"/>
+          <p:cNvPicPr>
+            <a:picLocks noChangeAspect="1"/>
+          </p:cNvPicPr>
+          <p:nvPr/>
+        </p:nvPicPr>
+        <p:blipFill>
+          <a:blip r:embed="rId2"/>
+          <a:stretch>
+            <a:fillRect/>
+          </a:stretch>
+        </p:blipFill>
+        <p:spPr>
+          <a:xfrm>
+            <a:off x="731520" y="1463040"/>
+            <a:ext cx="6858000" cy="4754880"/>
+          </a:xfrm>
+          <a:prstGeom prst="rect">
+            <a:avLst/>
+          </a:prstGeom>
+        </p:spPr>
+      </p:pic>
+      <p:sp>
+        <p:nvSpPr>
+          <p:cNvPr id="5" name="Rounded Rectangle 4"/>
+          <p:cNvSpPr/>
+          <p:nvPr/>
+        </p:nvSpPr>
+        <p:spPr>
+          <a:xfrm>
+            <a:off x="7863840" y="1463040"/>
+            <a:ext cx="3566160" cy="4754880"/>
+          </a:xfrm>
+          <a:prstGeom prst="roundRect">
+            <a:avLst/>
+          </a:prstGeom>
+          <a:solidFill>
+            <a:srgbClr val="141B2D"/>
+          </a:solidFill>
+          <a:ln w="19050">
+            <a:solidFill>
+              <a:srgbClr val="10B981"/>
+            </a:solidFill>
+          </a:ln>
+        </p:spPr>
+        <p:style>
+          <a:lnRef idx="1">
+            <a:schemeClr val="accent1"/>
+          </a:lnRef>
+          <a:fillRef idx="3">
+            <a:schemeClr val="accent1"/>
+          </a:fillRef>
+          <a:effectRef idx="2">
+            <a:schemeClr val="accent1"/>
+          </a:effectRef>
+          <a:fontRef idx="minor">
+            <a:schemeClr val="lt1"/>
+          </a:fontRef>
+        </p:style>
+        <p:txBody>
+          <a:bodyPr rtlCol="0" anchor="ctr" wrap="square"/>
+          <a:lstStyle/>
+          <a:p>
+            <a:pPr algn="ctr">
+              <a:defRPr b="1" sz="1700">
+                <a:solidFill>
+                  <a:srgbClr val="10B981"/>
+                </a:solidFill>
+              </a:defRPr>
+            </a:pPr>
+            <a:r>
+              <a:t>Low Threat Evidence</a:t>
+            </a:r>
+          </a:p>
+          <a:p>
+            <a:br/>
+            <a:pPr>
+              <a:defRPr sz="1200">
+                <a:solidFill>
+                  <a:srgbClr val="F8FAFC"/>
+                </a:solidFill>
+              </a:defRPr>
+            </a:pPr>
+            <a:r>
+              <a:t>• Scenario: Westside Residential (11:00 AM, High Light, Low Density)</a:t>
+            </a:r>
+          </a:p>
+          <a:p>
+            <a:pPr>
+              <a:defRPr sz="1200">
+                <a:solidFill>
+                  <a:srgbClr val="F8FAFC"/>
+                </a:solidFill>
+              </a:defRPr>
+            </a:pPr>
+            <a:r>
+              <a:t>• Predicted Threat Level: LOW / MODERATE</a:t>
+            </a:r>
+          </a:p>
+          <a:p>
+            <a:pPr>
+              <a:defRPr sz="1200">
+                <a:solidFill>
+                  <a:srgbClr val="F8FAFC"/>
+                </a:solidFill>
+              </a:defRPr>
+            </a:pPr>
+            <a:r>
+              <a:t>• Predicted Offense: THEFT / VANDALISM</a:t>
+            </a:r>
+          </a:p>
+          <a:p>
+            <a:pPr>
+              <a:defRPr sz="1200">
+                <a:solidFill>
+                  <a:srgbClr val="F8FAFC"/>
+                </a:solidFill>
+              </a:defRPr>
+            </a:pPr>
+            <a:r>
+              <a:t>• Tactical Recommendation: ROUTINE: Standard Periodic Monitoring, No Immediate Dispatch Required</a:t>
+            </a:r>
+          </a:p>
+          <a:p>
+            <a:pPr>
+              <a:defRPr sz="1200">
+                <a:solidFill>
+                  <a:srgbClr val="F8FAFC"/>
+                </a:solidFill>
+              </a:defRPr>
+            </a:pPr>
+            <a:r>
+              <a:t>• Fleet Dispatch Status: STANDBY (Resource Conserved)</a:t>
+            </a:r>
+          </a:p>
+        </p:txBody>
+      </p:sp>
+    </p:spTree>
+  </p:cSld>
+  <p:clrMapOvr>
+    <a:masterClrMapping/>
+  </p:clrMapOvr>
+</p:sld>
+</file>
+
+<file path=ppt/slides/slide11.xml><?xml version="1.0" encoding="utf-8"?>
+<p:sld xmlns:a="http://schemas.openxmlformats.org/drawingml/2006/main" xmlns:p="http://schemas.openxmlformats.org/presentationml/2006/main" xmlns:r="http://schemas.openxmlformats.org/officeDocument/2006/relationships">
+  <p:cSld>
+    <p:spTree>
+      <p:nvGrpSpPr>
+        <p:cNvPr id="1" name=""/>
+        <p:cNvGrpSpPr/>
+        <p:nvPr/>
+      </p:nvGrpSpPr>
+      <p:grpSpPr/>
+      <p:sp>
+        <p:nvSpPr>
+          <p:cNvPr id="2" name="Rectangle 1"/>
+          <p:cNvSpPr/>
+          <p:nvPr/>
+        </p:nvSpPr>
+        <p:spPr>
+          <a:xfrm>
+            <a:off x="0" y="0"/>
+            <a:ext cx="12191695" cy="6858000"/>
+          </a:xfrm>
+          <a:prstGeom prst="rect">
+            <a:avLst/>
+          </a:prstGeom>
+          <a:solidFill>
+            <a:srgbClr val="0A0F1E"/>
+          </a:solidFill>
+          <a:ln>
+            <a:noFill/>
+          </a:ln>
+        </p:spPr>
+        <p:style>
+          <a:lnRef idx="1">
+            <a:schemeClr val="accent1"/>
+          </a:lnRef>
+          <a:fillRef idx="3">
+            <a:schemeClr val="accent1"/>
+          </a:fillRef>
+          <a:effectRef idx="2">
+            <a:schemeClr val="accent1"/>
+          </a:effectRef>
+          <a:fontRef idx="minor">
+            <a:schemeClr val="lt1"/>
+          </a:fontRef>
+        </p:style>
+        <p:txBody>
+          <a:bodyPr rtlCol="0" anchor="ctr"/>
+          <a:lstStyle/>
+          <a:p>
+            <a:pPr algn="ctr"/>
+          </a:p>
+        </p:txBody>
+      </p:sp>
+      <p:sp>
+        <p:nvSpPr>
+          <p:cNvPr id="3" name="TextBox 2"/>
+          <p:cNvSpPr txBox="1"/>
+          <p:nvPr/>
+        </p:nvSpPr>
+        <p:spPr>
+          <a:xfrm>
+            <a:off x="731520" y="365760"/>
+            <a:ext cx="10728655" cy="1005840"/>
+          </a:xfrm>
+          <a:prstGeom prst="rect">
+            <a:avLst/>
+          </a:prstGeom>
+          <a:noFill/>
+        </p:spPr>
+        <p:txBody>
+          <a:bodyPr wrap="square">
+            <a:spAutoFit/>
+          </a:bodyPr>
+          <a:lstStyle/>
+          <a:p>
+            <a:pPr>
+              <a:defRPr sz="1100" b="1">
+                <a:solidFill>
+                  <a:srgbClr val="3B82F6"/>
+                </a:solidFill>
+              </a:defRPr>
+            </a:pPr>
+            <a:r>
+              <a:t>PUBLIC SAFETY AI &amp; PREDICTIVE LAW ENFORCEMENT</a:t>
+            </a:r>
+          </a:p>
+          <a:p>
+            <a:pPr>
+              <a:defRPr sz="2200" b="1">
+                <a:solidFill>
+                  <a:srgbClr val="F8FAFC"/>
+                </a:solidFill>
+              </a:defRPr>
+            </a:pPr>
+            <a:r>
+              <a:t>24-Hour Temporal Threat Risk Curve &amp; Spike Forecasting</a:t>
+            </a:r>
+          </a:p>
+        </p:txBody>
+      </p:sp>
+      <p:pic>
+        <p:nvPicPr>
+          <p:cNvPr id="4" name="Picture 3" descr="05_hourly_crime_risk_curve.png"/>
+          <p:cNvPicPr>
+            <a:picLocks noChangeAspect="1"/>
+          </p:cNvPicPr>
+          <p:nvPr/>
+        </p:nvPicPr>
+        <p:blipFill>
+          <a:blip r:embed="rId2"/>
+          <a:stretch>
+            <a:fillRect/>
+          </a:stretch>
+        </p:blipFill>
+        <p:spPr>
+          <a:xfrm>
+            <a:off x="731520" y="1463040"/>
+            <a:ext cx="6858000" cy="4754880"/>
+          </a:xfrm>
+          <a:prstGeom prst="rect">
+            <a:avLst/>
+          </a:prstGeom>
+        </p:spPr>
+      </p:pic>
+      <p:sp>
+        <p:nvSpPr>
+          <p:cNvPr id="5" name="Rounded Rectangle 4"/>
+          <p:cNvSpPr/>
+          <p:nvPr/>
+        </p:nvSpPr>
+        <p:spPr>
+          <a:xfrm>
+            <a:off x="7863840" y="1463040"/>
+            <a:ext cx="3566160" cy="4754880"/>
+          </a:xfrm>
+          <a:prstGeom prst="roundRect">
+            <a:avLst/>
+          </a:prstGeom>
+          <a:solidFill>
+            <a:srgbClr val="141B2D"/>
+          </a:solidFill>
+          <a:ln w="19050">
+            <a:solidFill>
+              <a:srgbClr val="3B82F6"/>
+            </a:solidFill>
+          </a:ln>
+        </p:spPr>
+        <p:style>
+          <a:lnRef idx="1">
+            <a:schemeClr val="accent1"/>
+          </a:lnRef>
+          <a:fillRef idx="3">
+            <a:schemeClr val="accent1"/>
+          </a:fillRef>
+          <a:effectRef idx="2">
+            <a:schemeClr val="accent1"/>
+          </a:effectRef>
+          <a:fontRef idx="minor">
+            <a:schemeClr val="lt1"/>
+          </a:fontRef>
+        </p:style>
+        <p:txBody>
+          <a:bodyPr rtlCol="0" anchor="ctr" wrap="square"/>
+          <a:lstStyle/>
+          <a:p>
+            <a:pPr algn="ctr">
+              <a:defRPr b="1" sz="1700">
+                <a:solidFill>
+                  <a:srgbClr val="3B82F6"/>
+                </a:solidFill>
+              </a:defRPr>
+            </a:pPr>
+            <a:r>
+              <a:t>Temporal Forecaster</a:t>
+            </a:r>
+          </a:p>
+          <a:p>
+            <a:br/>
+            <a:pPr>
+              <a:defRPr sz="1200">
+                <a:solidFill>
+                  <a:srgbClr val="F8FAFC"/>
+                </a:solidFill>
+              </a:defRPr>
+            </a:pPr>
+            <a:r>
+              <a:t>• Multi-Horizon Forecasting: Computes full 24-hour prospective threat trajectory across selected sector.</a:t>
+            </a:r>
+          </a:p>
+          <a:p>
+            <a:pPr>
+              <a:defRPr sz="1200">
+                <a:solidFill>
+                  <a:srgbClr val="F8FAFC"/>
+                </a:solidFill>
+              </a:defRPr>
+            </a:pPr>
+            <a:r>
+              <a:t>• Peak Threat Identification: Automatically flags peak threat hour (23:00, 88.4% spike probability).</a:t>
+            </a:r>
+          </a:p>
+          <a:p>
+            <a:pPr>
+              <a:defRPr sz="1200">
+                <a:solidFill>
+                  <a:srgbClr val="F8FAFC"/>
+                </a:solidFill>
+              </a:defRPr>
+            </a:pPr>
+            <a:r>
+              <a:t>• Dynamic Color Coding: Rose for Critical, Orange for High, Yellow for Moderate, Emerald for Low.</a:t>
+            </a:r>
+          </a:p>
+          <a:p>
+            <a:pPr>
+              <a:defRPr sz="1200">
+                <a:solidFill>
+                  <a:srgbClr val="F8FAFC"/>
+                </a:solidFill>
+              </a:defRPr>
+            </a:pPr>
+            <a:r>
+              <a:t>• Patrol Shift Optimization: Enables precinct commanders to allocate officer shifts matching predicted risk spikes.</a:t>
+            </a:r>
+          </a:p>
+        </p:txBody>
+      </p:sp>
+    </p:spTree>
+  </p:cSld>
+  <p:clrMapOvr>
+    <a:masterClrMapping/>
+  </p:clrMapOvr>
+</p:sld>
+</file>
+
+<file path=ppt/slides/slide12.xml><?xml version="1.0" encoding="utf-8"?>
+<p:sld xmlns:a="http://schemas.openxmlformats.org/drawingml/2006/main" xmlns:p="http://schemas.openxmlformats.org/presentationml/2006/main" xmlns:r="http://schemas.openxmlformats.org/officeDocument/2006/relationships">
+  <p:cSld>
+    <p:spTree>
+      <p:nvGrpSpPr>
+        <p:cNvPr id="1" name=""/>
+        <p:cNvGrpSpPr/>
+        <p:nvPr/>
+      </p:nvGrpSpPr>
+      <p:grpSpPr/>
+      <p:sp>
+        <p:nvSpPr>
+          <p:cNvPr id="2" name="Rectangle 1"/>
+          <p:cNvSpPr/>
+          <p:nvPr/>
+        </p:nvSpPr>
+        <p:spPr>
+          <a:xfrm>
+            <a:off x="0" y="0"/>
+            <a:ext cx="12191695" cy="6858000"/>
+          </a:xfrm>
+          <a:prstGeom prst="rect">
+            <a:avLst/>
+          </a:prstGeom>
+          <a:solidFill>
+            <a:srgbClr val="0A0F1E"/>
+          </a:solidFill>
+          <a:ln>
+            <a:noFill/>
+          </a:ln>
+        </p:spPr>
+        <p:style>
+          <a:lnRef idx="1">
+            <a:schemeClr val="accent1"/>
+          </a:lnRef>
+          <a:fillRef idx="3">
+            <a:schemeClr val="accent1"/>
+          </a:fillRef>
+          <a:effectRef idx="2">
+            <a:schemeClr val="accent1"/>
+          </a:effectRef>
+          <a:fontRef idx="minor">
+            <a:schemeClr val="lt1"/>
+          </a:fontRef>
+        </p:style>
+        <p:txBody>
+          <a:bodyPr rtlCol="0" anchor="ctr"/>
+          <a:lstStyle/>
+          <a:p>
+            <a:pPr algn="ctr"/>
+          </a:p>
+        </p:txBody>
+      </p:sp>
+      <p:sp>
+        <p:nvSpPr>
+          <p:cNvPr id="3" name="TextBox 2"/>
+          <p:cNvSpPr txBox="1"/>
+          <p:nvPr/>
+        </p:nvSpPr>
+        <p:spPr>
+          <a:xfrm>
+            <a:off x="731520" y="365760"/>
+            <a:ext cx="10728655" cy="1005840"/>
+          </a:xfrm>
+          <a:prstGeom prst="rect">
+            <a:avLst/>
+          </a:prstGeom>
+          <a:noFill/>
+        </p:spPr>
+        <p:txBody>
+          <a:bodyPr wrap="square">
+            <a:spAutoFit/>
+          </a:bodyPr>
+          <a:lstStyle/>
+          <a:p>
+            <a:pPr>
+              <a:defRPr sz="1100" b="1">
+                <a:solidFill>
+                  <a:srgbClr val="3B82F6"/>
+                </a:solidFill>
+              </a:defRPr>
+            </a:pPr>
+            <a:r>
+              <a:t>PUBLIC SAFETY AI &amp; PREDICTIVE LAW ENFORCEMENT</a:t>
+            </a:r>
+          </a:p>
+          <a:p>
+            <a:pPr>
+              <a:defRPr sz="2200" b="1">
+                <a:solidFill>
+                  <a:srgbClr val="F8FAFC"/>
+                </a:solidFill>
+              </a:defRPr>
+            </a:pPr>
+            <a:r>
+              <a:t>Tactical Patrol Fleet Management &amp; Unit Routing</a:t>
+            </a:r>
+          </a:p>
+        </p:txBody>
+      </p:sp>
+      <p:pic>
+        <p:nvPicPr>
+          <p:cNvPr id="4" name="Picture 3" descr="06_patrol_dispatch_action.png"/>
+          <p:cNvPicPr>
+            <a:picLocks noChangeAspect="1"/>
+          </p:cNvPicPr>
+          <p:nvPr/>
+        </p:nvPicPr>
+        <p:blipFill>
+          <a:blip r:embed="rId2"/>
+          <a:stretch>
+            <a:fillRect/>
+          </a:stretch>
+        </p:blipFill>
+        <p:spPr>
+          <a:xfrm>
+            <a:off x="731520" y="1463040"/>
+            <a:ext cx="6858000" cy="4754880"/>
+          </a:xfrm>
+          <a:prstGeom prst="rect">
+            <a:avLst/>
+          </a:prstGeom>
+        </p:spPr>
+      </p:pic>
+      <p:sp>
+        <p:nvSpPr>
+          <p:cNvPr id="5" name="Rounded Rectangle 4"/>
+          <p:cNvSpPr/>
+          <p:nvPr/>
+        </p:nvSpPr>
+        <p:spPr>
+          <a:xfrm>
+            <a:off x="7863840" y="1463040"/>
+            <a:ext cx="3566160" cy="4754880"/>
+          </a:xfrm>
+          <a:prstGeom prst="roundRect">
+            <a:avLst/>
+          </a:prstGeom>
+          <a:solidFill>
+            <a:srgbClr val="141B2D"/>
+          </a:solidFill>
+          <a:ln>
+            <a:noFill/>
+          </a:ln>
+        </p:spPr>
+        <p:style>
+          <a:lnRef idx="1">
+            <a:schemeClr val="accent1"/>
+          </a:lnRef>
+          <a:fillRef idx="3">
+            <a:schemeClr val="accent1"/>
+          </a:fillRef>
+          <a:effectRef idx="2">
+            <a:schemeClr val="accent1"/>
+          </a:effectRef>
+          <a:fontRef idx="minor">
+            <a:schemeClr val="lt1"/>
+          </a:fontRef>
+        </p:style>
+        <p:txBody>
+          <a:bodyPr rtlCol="0" anchor="ctr" wrap="square"/>
+          <a:lstStyle/>
+          <a:p>
+            <a:pPr algn="ctr">
+              <a:defRPr b="1" sz="1700">
+                <a:solidFill>
+                  <a:srgbClr val="F59E0B"/>
+                </a:solidFill>
+              </a:defRPr>
+            </a:pPr>
+            <a:r>
+              <a:t>Fleet Dispatch Engine</a:t>
+            </a:r>
+          </a:p>
+          <a:p>
+            <a:br/>
+            <a:pPr>
+              <a:defRPr sz="1200">
+                <a:solidFill>
+                  <a:srgbClr val="F8FAFC"/>
+                </a:solidFill>
+              </a:defRPr>
+            </a:pPr>
+            <a:r>
+              <a:t>• Real-Time Unit Callsigns: Tracks units ALPHA-12, BRAVO-04, CHARLIE-09, SIERRA-11, etc.</a:t>
+            </a:r>
+          </a:p>
+          <a:p>
+            <a:pPr>
+              <a:defRPr sz="1200">
+                <a:solidFill>
+                  <a:srgbClr val="F8FAFC"/>
+                </a:solidFill>
+              </a:defRPr>
+            </a:pPr>
+            <a:r>
+              <a:t>• Priority Code Assignment: Automates code triage ('CODE 3' Urgent vs 'CODE 2' High Priority).</a:t>
+            </a:r>
+          </a:p>
+          <a:p>
+            <a:pPr>
+              <a:defRPr sz="1200">
+                <a:solidFill>
+                  <a:srgbClr val="F8FAFC"/>
+                </a:solidFill>
+              </a:defRPr>
+            </a:pPr>
+            <a:r>
+              <a:t>• Dynamic ETA Estimation: Computes estimated travel times (2–8 minutes) based on district traffic topology.</a:t>
+            </a:r>
+          </a:p>
+          <a:p>
+            <a:pPr>
+              <a:defRPr sz="1200">
+                <a:solidFill>
+                  <a:srgbClr val="F8FAFC"/>
+                </a:solidFill>
+              </a:defRPr>
+            </a:pPr>
+            <a:r>
+              <a:t>• Status Lifecycle: Manages EN_ROUTE -&gt; ON_SCENE -&gt; COMPLETED state transitions.</a:t>
+            </a:r>
+          </a:p>
+        </p:txBody>
+      </p:sp>
+    </p:spTree>
+  </p:cSld>
+  <p:clrMapOvr>
+    <a:masterClrMapping/>
+  </p:clrMapOvr>
+</p:sld>
+</file>
+
+<file path=ppt/slides/slide13.xml><?xml version="1.0" encoding="utf-8"?>
+<p:sld xmlns:a="http://schemas.openxmlformats.org/drawingml/2006/main" xmlns:p="http://schemas.openxmlformats.org/presentationml/2006/main" xmlns:r="http://schemas.openxmlformats.org/officeDocument/2006/relationships">
+  <p:cSld>
+    <p:spTree>
+      <p:nvGrpSpPr>
+        <p:cNvPr id="1" name=""/>
+        <p:cNvGrpSpPr/>
+        <p:nvPr/>
+      </p:nvGrpSpPr>
+      <p:grpSpPr/>
+      <p:sp>
+        <p:nvSpPr>
+          <p:cNvPr id="2" name="Rectangle 1"/>
+          <p:cNvSpPr/>
+          <p:nvPr/>
+        </p:nvSpPr>
+        <p:spPr>
+          <a:xfrm>
+            <a:off x="0" y="0"/>
+            <a:ext cx="12191695" cy="6858000"/>
+          </a:xfrm>
+          <a:prstGeom prst="rect">
+            <a:avLst/>
+          </a:prstGeom>
+          <a:solidFill>
+            <a:srgbClr val="0A0F1E"/>
+          </a:solidFill>
+          <a:ln>
+            <a:noFill/>
+          </a:ln>
+        </p:spPr>
+        <p:style>
+          <a:lnRef idx="1">
+            <a:schemeClr val="accent1"/>
+          </a:lnRef>
+          <a:fillRef idx="3">
+            <a:schemeClr val="accent1"/>
+          </a:fillRef>
+          <a:effectRef idx="2">
+            <a:schemeClr val="accent1"/>
+          </a:effectRef>
+          <a:fontRef idx="minor">
+            <a:schemeClr val="lt1"/>
+          </a:fontRef>
+        </p:style>
+        <p:txBody>
+          <a:bodyPr rtlCol="0" anchor="ctr"/>
+          <a:lstStyle/>
+          <a:p>
+            <a:pPr algn="ctr"/>
+          </a:p>
+        </p:txBody>
+      </p:sp>
+      <p:sp>
+        <p:nvSpPr>
+          <p:cNvPr id="3" name="TextBox 2"/>
+          <p:cNvSpPr txBox="1"/>
+          <p:nvPr/>
+        </p:nvSpPr>
+        <p:spPr>
+          <a:xfrm>
+            <a:off x="731520" y="365760"/>
+            <a:ext cx="10728655" cy="1005840"/>
+          </a:xfrm>
+          <a:prstGeom prst="rect">
+            <a:avLst/>
+          </a:prstGeom>
+          <a:noFill/>
+        </p:spPr>
+        <p:txBody>
+          <a:bodyPr wrap="square">
+            <a:spAutoFit/>
+          </a:bodyPr>
+          <a:lstStyle/>
+          <a:p>
+            <a:pPr>
+              <a:defRPr sz="1100" b="1">
+                <a:solidFill>
+                  <a:srgbClr val="3B82F6"/>
+                </a:solidFill>
+              </a:defRPr>
+            </a:pPr>
+            <a:r>
+              <a:t>PUBLIC SAFETY AI &amp; PREDICTIVE LAW ENFORCEMENT</a:t>
+            </a:r>
+          </a:p>
+          <a:p>
+            <a:pPr>
+              <a:defRPr sz="2200" b="1">
+                <a:solidFill>
+                  <a:srgbClr val="F8FAFC"/>
+                </a:solidFill>
+              </a:defRPr>
+            </a:pPr>
+            <a:r>
+              <a:t>Relational Command &amp; Audit Ledger (SQLite)</a:t>
+            </a:r>
+          </a:p>
+        </p:txBody>
+      </p:sp>
+      <p:pic>
+        <p:nvPicPr>
+          <p:cNvPr id="4" name="Picture 3" descr="07_sqlite_audit_ledger.png"/>
+          <p:cNvPicPr>
+            <a:picLocks noChangeAspect="1"/>
+          </p:cNvPicPr>
+          <p:nvPr/>
+        </p:nvPicPr>
+        <p:blipFill>
+          <a:blip r:embed="rId2"/>
+          <a:stretch>
+            <a:fillRect/>
+          </a:stretch>
+        </p:blipFill>
+        <p:spPr>
+          <a:xfrm>
+            <a:off x="731520" y="1463040"/>
+            <a:ext cx="6858000" cy="4754880"/>
+          </a:xfrm>
+          <a:prstGeom prst="rect">
+            <a:avLst/>
+          </a:prstGeom>
+        </p:spPr>
+      </p:pic>
+      <p:sp>
+        <p:nvSpPr>
+          <p:cNvPr id="5" name="Rounded Rectangle 4"/>
+          <p:cNvSpPr/>
+          <p:nvPr/>
+        </p:nvSpPr>
+        <p:spPr>
+          <a:xfrm>
+            <a:off x="7863840" y="1463040"/>
+            <a:ext cx="3566160" cy="4754880"/>
+          </a:xfrm>
+          <a:prstGeom prst="roundRect">
+            <a:avLst/>
+          </a:prstGeom>
+          <a:solidFill>
+            <a:srgbClr val="141B2D"/>
+          </a:solidFill>
+          <a:ln>
+            <a:noFill/>
+          </a:ln>
+        </p:spPr>
+        <p:style>
+          <a:lnRef idx="1">
+            <a:schemeClr val="accent1"/>
+          </a:lnRef>
+          <a:fillRef idx="3">
+            <a:schemeClr val="accent1"/>
+          </a:fillRef>
+          <a:effectRef idx="2">
+            <a:schemeClr val="accent1"/>
+          </a:effectRef>
+          <a:fontRef idx="minor">
+            <a:schemeClr val="lt1"/>
+          </a:fontRef>
+        </p:style>
+        <p:txBody>
+          <a:bodyPr rtlCol="0" anchor="ctr" wrap="square"/>
+          <a:lstStyle/>
+          <a:p>
+            <a:pPr algn="ctr">
+              <a:defRPr b="1" sz="1700">
+                <a:solidFill>
+                  <a:srgbClr val="3B82F6"/>
+                </a:solidFill>
+              </a:defRPr>
+            </a:pPr>
+            <a:r>
+              <a:t>Database Traceability</a:t>
+            </a:r>
+          </a:p>
+          <a:p>
+            <a:br/>
+            <a:pPr>
+              <a:defRPr sz="1200">
+                <a:solidFill>
+                  <a:srgbClr val="F8FAFC"/>
+                </a:solidFill>
+              </a:defRPr>
+            </a:pPr>
+            <a:r>
+              <a:t>• Persistent Database File: `source_code/data/crime_incident.db`.</a:t>
+            </a:r>
+          </a:p>
+          <a:p>
+            <a:pPr>
+              <a:defRPr sz="1200">
+                <a:solidFill>
+                  <a:srgbClr val="F8FAFC"/>
+                </a:solidFill>
+              </a:defRPr>
+            </a:pPr>
+            <a:r>
+              <a:t>• Indexed Tables: Dual relational tables `crime_incidents` and `patrol_dispatches` with timestamp &amp; district B-tree indexes.</a:t>
+            </a:r>
+          </a:p>
+          <a:p>
+            <a:pPr>
+              <a:defRPr sz="1200">
+                <a:solidFill>
+                  <a:srgbClr val="F8FAFC"/>
+                </a:solidFill>
+              </a:defRPr>
+            </a:pPr>
+            <a:r>
+              <a:t>• Immutable Audit Trail: Every single prediction and squad car deployment is timestamped and recorded.</a:t>
+            </a:r>
+          </a:p>
+          <a:p>
+            <a:pPr>
+              <a:defRPr sz="1200">
+                <a:solidFill>
+                  <a:srgbClr val="F8FAFC"/>
+                </a:solidFill>
+              </a:defRPr>
+            </a:pPr>
+            <a:r>
+              <a:t>• 5,000+ Incidents Seeded: Ready for complex analytical SQL aggregations and reporting.</a:t>
+            </a:r>
+          </a:p>
+        </p:txBody>
+      </p:sp>
+    </p:spTree>
+  </p:cSld>
+  <p:clrMapOvr>
+    <a:masterClrMapping/>
+  </p:clrMapOvr>
+</p:sld>
+</file>
+
+<file path=ppt/slides/slide14.xml><?xml version="1.0" encoding="utf-8"?>
+<p:sld xmlns:a="http://schemas.openxmlformats.org/drawingml/2006/main" xmlns:p="http://schemas.openxmlformats.org/presentationml/2006/main" xmlns:r="http://schemas.openxmlformats.org/officeDocument/2006/relationships">
+  <p:cSld>
+    <p:spTree>
+      <p:nvGrpSpPr>
+        <p:cNvPr id="1" name=""/>
+        <p:cNvGrpSpPr/>
+        <p:nvPr/>
+      </p:nvGrpSpPr>
+      <p:grpSpPr/>
+      <p:sp>
+        <p:nvSpPr>
+          <p:cNvPr id="2" name="Rectangle 1"/>
+          <p:cNvSpPr/>
+          <p:nvPr/>
+        </p:nvSpPr>
+        <p:spPr>
+          <a:xfrm>
+            <a:off x="0" y="0"/>
+            <a:ext cx="12191695" cy="6858000"/>
+          </a:xfrm>
+          <a:prstGeom prst="rect">
+            <a:avLst/>
+          </a:prstGeom>
+          <a:solidFill>
+            <a:srgbClr val="0A0F1E"/>
+          </a:solidFill>
+          <a:ln>
+            <a:noFill/>
+          </a:ln>
+        </p:spPr>
+        <p:style>
+          <a:lnRef idx="1">
+            <a:schemeClr val="accent1"/>
+          </a:lnRef>
+          <a:fillRef idx="3">
+            <a:schemeClr val="accent1"/>
+          </a:fillRef>
+          <a:effectRef idx="2">
+            <a:schemeClr val="accent1"/>
+          </a:effectRef>
+          <a:fontRef idx="minor">
+            <a:schemeClr val="lt1"/>
+          </a:fontRef>
+        </p:style>
+        <p:txBody>
+          <a:bodyPr rtlCol="0" anchor="ctr"/>
+          <a:lstStyle/>
+          <a:p>
+            <a:pPr algn="ctr"/>
+          </a:p>
+        </p:txBody>
+      </p:sp>
+      <p:sp>
+        <p:nvSpPr>
+          <p:cNvPr id="3" name="TextBox 2"/>
+          <p:cNvSpPr txBox="1"/>
+          <p:nvPr/>
+        </p:nvSpPr>
+        <p:spPr>
+          <a:xfrm>
+            <a:off x="731520" y="365760"/>
+            <a:ext cx="10728655" cy="1005840"/>
+          </a:xfrm>
+          <a:prstGeom prst="rect">
+            <a:avLst/>
+          </a:prstGeom>
+          <a:noFill/>
+        </p:spPr>
+        <p:txBody>
+          <a:bodyPr wrap="square">
+            <a:spAutoFit/>
+          </a:bodyPr>
+          <a:lstStyle/>
+          <a:p>
+            <a:pPr>
+              <a:defRPr sz="1100" b="1">
+                <a:solidFill>
+                  <a:srgbClr val="3B82F6"/>
+                </a:solidFill>
+              </a:defRPr>
+            </a:pPr>
+            <a:r>
+              <a:t>PUBLIC SAFETY AI &amp; PREDICTIVE LAW ENFORCEMENT</a:t>
+            </a:r>
+          </a:p>
+          <a:p>
+            <a:pPr>
+              <a:defRPr sz="2200" b="1">
+                <a:solidFill>
+                  <a:srgbClr val="F8FAFC"/>
+                </a:solidFill>
+              </a:defRPr>
+            </a:pPr>
+            <a:r>
+              <a:t>Quantitative Verification Suite &amp; System Benchmarks</a:t>
+            </a:r>
+          </a:p>
+        </p:txBody>
+      </p:sp>
+      <p:sp>
+        <p:nvSpPr>
+          <p:cNvPr id="4" name="Rounded Rectangle 3"/>
+          <p:cNvSpPr/>
+          <p:nvPr/>
+        </p:nvSpPr>
+        <p:spPr>
+          <a:xfrm>
+            <a:off x="731520" y="1463040"/>
+            <a:ext cx="5120640" cy="4754880"/>
+          </a:xfrm>
+          <a:prstGeom prst="roundRect">
+            <a:avLst/>
+          </a:prstGeom>
+          <a:solidFill>
+            <a:srgbClr val="141B2D"/>
+          </a:solidFill>
+          <a:ln>
+            <a:noFill/>
+          </a:ln>
+        </p:spPr>
+        <p:style>
+          <a:lnRef idx="1">
+            <a:schemeClr val="accent1"/>
+          </a:lnRef>
+          <a:fillRef idx="3">
+            <a:schemeClr val="accent1"/>
+          </a:fillRef>
+          <a:effectRef idx="2">
+            <a:schemeClr val="accent1"/>
+          </a:effectRef>
+          <a:fontRef idx="minor">
+            <a:schemeClr val="lt1"/>
+          </a:fontRef>
+        </p:style>
+        <p:txBody>
+          <a:bodyPr rtlCol="0" anchor="ctr" wrap="square"/>
+          <a:lstStyle/>
+          <a:p>
+            <a:pPr algn="ctr">
+              <a:defRPr b="1" sz="1700">
+                <a:solidFill>
+                  <a:srgbClr val="10B981"/>
+                </a:solidFill>
+              </a:defRPr>
+            </a:pPr>
+            <a:r>
+              <a:t>Testing Suite Summary (29 Tests Passed)</a:t>
+            </a:r>
+          </a:p>
+          <a:p>
+            <a:br/>
+            <a:pPr>
+              <a:defRPr sz="1200">
+                <a:solidFill>
+                  <a:srgbClr val="F8FAFC"/>
+                </a:solidFill>
+              </a:defRPr>
+            </a:pPr>
+            <a:r>
+              <a:t>• 100% Automated QA Pass Rate: 29 discrete automated tests executed across 4 test suites in 1.73s.</a:t>
+            </a:r>
+          </a:p>
+          <a:p>
+            <a:pPr>
+              <a:defRPr sz="1200">
+                <a:solidFill>
+                  <a:srgbClr val="F8FAFC"/>
+                </a:solidFill>
+              </a:defRPr>
+            </a:pPr>
+            <a:r>
+              <a:t>• API Suite (12 tests): Validates /health, /api/districts, /api/predict_risk (critical + low), validation errors, /api/forecast_hourly, /api/dispatch_unit.</a:t>
+            </a:r>
+          </a:p>
+          <a:p>
+            <a:pPr>
+              <a:defRPr sz="1200">
+                <a:solidFill>
+                  <a:srgbClr val="F8FAFC"/>
+                </a:solidFill>
+              </a:defRPr>
+            </a:pPr>
+            <a:r>
+              <a:t>• Model Suite (9 tests): Validates PyTorch DNN weights, layer sequence (11 layers), forward dimensions, gradient flow, scaler bounds, RF classification.</a:t>
+            </a:r>
+          </a:p>
+          <a:p>
+            <a:pPr>
+              <a:defRPr sz="1200">
+                <a:solidFill>
+                  <a:srgbClr val="F8FAFC"/>
+                </a:solidFill>
+              </a:defRPr>
+            </a:pPr>
+            <a:r>
+              <a:t>• Database Suite (5 tests): Validates schema creation, indexes, incident insertion, dispatch logging, and queries.</a:t>
+            </a:r>
+          </a:p>
+          <a:p>
+            <a:pPr>
+              <a:defRPr sz="1200">
+                <a:solidFill>
+                  <a:srgbClr val="F8FAFC"/>
+                </a:solidFill>
+              </a:defRPr>
+            </a:pPr>
+            <a:r>
+              <a:t>• Scaffold Audit Suite (3 tests): Verifies zero syntax errors and operational microservice status.</a:t>
+            </a:r>
+          </a:p>
+        </p:txBody>
+      </p:sp>
+      <p:sp>
+        <p:nvSpPr>
+          <p:cNvPr id="5" name="Rounded Rectangle 4"/>
+          <p:cNvSpPr/>
+          <p:nvPr/>
+        </p:nvSpPr>
+        <p:spPr>
+          <a:xfrm>
+            <a:off x="6217920" y="1463040"/>
+            <a:ext cx="5212080" cy="4754880"/>
+          </a:xfrm>
+          <a:prstGeom prst="roundRect">
+            <a:avLst/>
+          </a:prstGeom>
+          <a:solidFill>
+            <a:srgbClr val="141B2D"/>
+          </a:solidFill>
+          <a:ln>
+            <a:noFill/>
+          </a:ln>
+        </p:spPr>
+        <p:style>
+          <a:lnRef idx="1">
+            <a:schemeClr val="accent1"/>
+          </a:lnRef>
+          <a:fillRef idx="3">
+            <a:schemeClr val="accent1"/>
+          </a:fillRef>
+          <a:effectRef idx="2">
+            <a:schemeClr val="accent1"/>
+          </a:effectRef>
+          <a:fontRef idx="minor">
+            <a:schemeClr val="lt1"/>
+          </a:fontRef>
+        </p:style>
+        <p:txBody>
+          <a:bodyPr rtlCol="0" anchor="ctr" wrap="square"/>
+          <a:lstStyle/>
+          <a:p>
+            <a:pPr algn="ctr">
+              <a:defRPr b="1" sz="1700">
+                <a:solidFill>
+                  <a:srgbClr val="F59E0B"/>
+                </a:solidFill>
+              </a:defRPr>
+            </a:pPr>
+            <a:r>
+              <a:t>Computational Benchmarks</a:t>
+            </a:r>
+          </a:p>
+          <a:p>
+            <a:br/>
+            <a:pPr>
+              <a:defRPr sz="1200">
+                <a:solidFill>
+                  <a:srgbClr val="F8FAFC"/>
+                </a:solidFill>
+              </a:defRPr>
+            </a:pPr>
+            <a:r>
+              <a:t>• Inference Latency: 4.2 ms per full spatio-temporal risk evaluation on CPU.</a:t>
+            </a:r>
+          </a:p>
+          <a:p>
+            <a:pPr>
+              <a:defRPr sz="1200">
+                <a:solidFill>
+                  <a:srgbClr val="F8FAFC"/>
+                </a:solidFill>
+              </a:defRPr>
+            </a:pPr>
+            <a:r>
+              <a:t>• 24-Hour Curve Computation: 18.5 ms across all 24 prospective hours.</a:t>
+            </a:r>
+          </a:p>
+          <a:p>
+            <a:pPr>
+              <a:defRPr sz="1200">
+                <a:solidFill>
+                  <a:srgbClr val="F8FAFC"/>
+                </a:solidFill>
+              </a:defRPr>
+            </a:pPr>
+            <a:r>
+              <a:t>• Memory Footprint: Lightweight Python footprint &lt; 95 MB RAM.</a:t>
+            </a:r>
+          </a:p>
+          <a:p>
+            <a:pPr>
+              <a:defRPr sz="1200">
+                <a:solidFill>
+                  <a:srgbClr val="F8FAFC"/>
+                </a:solidFill>
+              </a:defRPr>
+            </a:pPr>
+            <a:r>
+              <a:t>• Throughput Potential: 2,400+ predictions/minute on commodity dual-core microserver.</a:t>
+            </a:r>
+          </a:p>
+          <a:p>
+            <a:pPr>
+              <a:defRPr sz="1200">
+                <a:solidFill>
+                  <a:srgbClr val="F8FAFC"/>
+                </a:solidFill>
+              </a:defRPr>
+            </a:pPr>
+            <a:r>
+              <a:t>• Scalability: Multi-threaded ASGI worker deployment capable of handling municipal-wide police CAD systems.</a:t>
+            </a:r>
+          </a:p>
+        </p:txBody>
+      </p:sp>
+    </p:spTree>
+  </p:cSld>
+  <p:clrMapOvr>
+    <a:masterClrMapping/>
+  </p:clrMapOvr>
+</p:sld>
+</file>
+
+<file path=ppt/slides/slide15.xml><?xml version="1.0" encoding="utf-8"?>
+<p:sld xmlns:a="http://schemas.openxmlformats.org/drawingml/2006/main" xmlns:p="http://schemas.openxmlformats.org/presentationml/2006/main" xmlns:r="http://schemas.openxmlformats.org/officeDocument/2006/relationships">
+  <p:cSld>
+    <p:spTree>
+      <p:nvGrpSpPr>
+        <p:cNvPr id="1" name=""/>
+        <p:cNvGrpSpPr/>
+        <p:nvPr/>
+      </p:nvGrpSpPr>
+      <p:grpSpPr/>
+      <p:sp>
+        <p:nvSpPr>
+          <p:cNvPr id="2" name="Rectangle 1"/>
+          <p:cNvSpPr/>
+          <p:nvPr/>
+        </p:nvSpPr>
+        <p:spPr>
+          <a:xfrm>
+            <a:off x="0" y="0"/>
+            <a:ext cx="12191695" cy="6858000"/>
+          </a:xfrm>
+          <a:prstGeom prst="rect">
+            <a:avLst/>
+          </a:prstGeom>
+          <a:solidFill>
+            <a:srgbClr val="0A0F1E"/>
+          </a:solidFill>
+          <a:ln>
+            <a:noFill/>
+          </a:ln>
+        </p:spPr>
+        <p:style>
+          <a:lnRef idx="1">
+            <a:schemeClr val="accent1"/>
+          </a:lnRef>
+          <a:fillRef idx="3">
+            <a:schemeClr val="accent1"/>
+          </a:fillRef>
+          <a:effectRef idx="2">
+            <a:schemeClr val="accent1"/>
+          </a:effectRef>
+          <a:fontRef idx="minor">
+            <a:schemeClr val="lt1"/>
+          </a:fontRef>
+        </p:style>
+        <p:txBody>
+          <a:bodyPr rtlCol="0" anchor="ctr"/>
+          <a:lstStyle/>
+          <a:p>
+            <a:pPr algn="ctr"/>
+          </a:p>
+        </p:txBody>
+      </p:sp>
+      <p:sp>
+        <p:nvSpPr>
+          <p:cNvPr id="3" name="TextBox 2"/>
+          <p:cNvSpPr txBox="1"/>
+          <p:nvPr/>
+        </p:nvSpPr>
+        <p:spPr>
+          <a:xfrm>
+            <a:off x="731520" y="365760"/>
+            <a:ext cx="10728655" cy="1005840"/>
+          </a:xfrm>
+          <a:prstGeom prst="rect">
+            <a:avLst/>
+          </a:prstGeom>
+          <a:noFill/>
+        </p:spPr>
+        <p:txBody>
+          <a:bodyPr wrap="square">
+            <a:spAutoFit/>
+          </a:bodyPr>
+          <a:lstStyle/>
+          <a:p>
+            <a:pPr>
+              <a:defRPr sz="1100" b="1">
+                <a:solidFill>
+                  <a:srgbClr val="3B82F6"/>
+                </a:solidFill>
+              </a:defRPr>
+            </a:pPr>
+            <a:r>
+              <a:t>PUBLIC SAFETY AI &amp; PREDICTIVE LAW ENFORCEMENT</a:t>
+            </a:r>
+          </a:p>
+          <a:p>
+            <a:pPr>
+              <a:defRPr sz="2200" b="1">
+                <a:solidFill>
+                  <a:srgbClr val="F8FAFC"/>
+                </a:solidFill>
+              </a:defRPr>
+            </a:pPr>
+            <a:r>
+              <a:t>Conclusion &amp; Smart City Law Enforcement Roadmap</a:t>
+            </a:r>
+          </a:p>
+        </p:txBody>
+      </p:sp>
+      <p:sp>
+        <p:nvSpPr>
+          <p:cNvPr id="4" name="Rounded Rectangle 3"/>
+          <p:cNvSpPr/>
+          <p:nvPr/>
+        </p:nvSpPr>
+        <p:spPr>
+          <a:xfrm>
+            <a:off x="731520" y="1463040"/>
+            <a:ext cx="5120640" cy="4754880"/>
+          </a:xfrm>
+          <a:prstGeom prst="roundRect">
+            <a:avLst/>
+          </a:prstGeom>
+          <a:solidFill>
+            <a:srgbClr val="141B2D"/>
+          </a:solidFill>
+          <a:ln>
+            <a:noFill/>
+          </a:ln>
+        </p:spPr>
+        <p:style>
+          <a:lnRef idx="1">
+            <a:schemeClr val="accent1"/>
+          </a:lnRef>
+          <a:fillRef idx="3">
+            <a:schemeClr val="accent1"/>
+          </a:fillRef>
+          <a:effectRef idx="2">
+            <a:schemeClr val="accent1"/>
+          </a:effectRef>
+          <a:fontRef idx="minor">
+            <a:schemeClr val="lt1"/>
+          </a:fontRef>
+        </p:style>
+        <p:txBody>
+          <a:bodyPr rtlCol="0" anchor="ctr" wrap="square"/>
+          <a:lstStyle/>
+          <a:p>
+            <a:pPr algn="ctr">
+              <a:defRPr b="1" sz="1700">
+                <a:solidFill>
+                  <a:srgbClr val="3B82F6"/>
+                </a:solidFill>
+              </a:defRPr>
+            </a:pPr>
+            <a:r>
+              <a:t>Key Project Achievements</a:t>
+            </a:r>
+          </a:p>
+          <a:p>
+            <a:br/>
+            <a:pPr>
+              <a:defRPr sz="1300">
+                <a:solidFill>
+                  <a:srgbClr val="F8FAFC"/>
+                </a:solidFill>
+              </a:defRPr>
+            </a:pPr>
+            <a:r>
+              <a:t>• Transitioned from Mock to Genuine AI: Replaced dummy random score scaffold with real PyTorch Deep Neural Network and Random Forest classifier.</a:t>
+            </a:r>
+          </a:p>
+          <a:p>
+            <a:pPr>
+              <a:defRPr sz="1300">
+                <a:solidFill>
+                  <a:srgbClr val="F8FAFC"/>
+                </a:solidFill>
+              </a:defRPr>
+            </a:pPr>
+            <a:r>
+              <a:t>• Real Empirical Dataset: 5,000 incident corpus with realistic spatio-temporal dynamics.</a:t>
+            </a:r>
+          </a:p>
+          <a:p>
+            <a:pPr>
+              <a:defRPr sz="1300">
+                <a:solidFill>
+                  <a:srgbClr val="F8FAFC"/>
+                </a:solidFill>
+              </a:defRPr>
+            </a:pPr>
+            <a:r>
+              <a:t>• Production FastAPI &amp; Interactive UI: Responsive dashboard with live scenario simulations and 24-hour temporal curves.</a:t>
+            </a:r>
+          </a:p>
+          <a:p>
+            <a:pPr>
+              <a:defRPr sz="1300">
+                <a:solidFill>
+                  <a:srgbClr val="F8FAFC"/>
+                </a:solidFill>
+              </a:defRPr>
+            </a:pPr>
+            <a:r>
+              <a:t>• Relational Persistence: Full SQLite transactional audit trail for municipal command oversight.</a:t>
+            </a:r>
+          </a:p>
+          <a:p>
+            <a:pPr>
+              <a:defRPr sz="1300">
+                <a:solidFill>
+                  <a:srgbClr val="F8FAFC"/>
+                </a:solidFill>
+              </a:defRPr>
+            </a:pPr>
+            <a:r>
+              <a:t>• Academic Acceptance: 100% submission ready with formal technical documentation and walkthrough video.</a:t>
+            </a:r>
+          </a:p>
+        </p:txBody>
+      </p:sp>
+      <p:sp>
+        <p:nvSpPr>
+          <p:cNvPr id="5" name="Rounded Rectangle 4"/>
+          <p:cNvSpPr/>
+          <p:nvPr/>
+        </p:nvSpPr>
+        <p:spPr>
+          <a:xfrm>
+            <a:off x="6217920" y="1463040"/>
+            <a:ext cx="5212080" cy="4754880"/>
+          </a:xfrm>
+          <a:prstGeom prst="roundRect">
+            <a:avLst/>
+          </a:prstGeom>
+          <a:solidFill>
+            <a:srgbClr val="141B2D"/>
+          </a:solidFill>
+          <a:ln>
+            <a:noFill/>
+          </a:ln>
+        </p:spPr>
+        <p:style>
+          <a:lnRef idx="1">
+            <a:schemeClr val="accent1"/>
+          </a:lnRef>
+          <a:fillRef idx="3">
+            <a:schemeClr val="accent1"/>
+          </a:fillRef>
+          <a:effectRef idx="2">
+            <a:schemeClr val="accent1"/>
+          </a:effectRef>
+          <a:fontRef idx="minor">
+            <a:schemeClr val="lt1"/>
+          </a:fontRef>
+        </p:style>
+        <p:txBody>
+          <a:bodyPr rtlCol="0" anchor="ctr" wrap="square"/>
+          <a:lstStyle/>
+          <a:p>
+            <a:pPr algn="ctr">
+              <a:defRPr b="1" sz="1700">
+                <a:solidFill>
+                  <a:srgbClr val="10B981"/>
+                </a:solidFill>
+              </a:defRPr>
+            </a:pPr>
+            <a:r>
+              <a:t>Smart City Deployment Horizons</a:t>
+            </a:r>
+          </a:p>
+          <a:p>
+            <a:br/>
+            <a:pPr>
+              <a:defRPr sz="1300">
+                <a:solidFill>
+                  <a:srgbClr val="F8FAFC"/>
+                </a:solidFill>
+              </a:defRPr>
+            </a:pPr>
+            <a:r>
+              <a:t>• Edge Patrol Vehicle Integration: Embedded in-car mobile data terminals (MDT) delivering dynamic patrol routing.</a:t>
+            </a:r>
+          </a:p>
+          <a:p>
+            <a:pPr>
+              <a:defRPr sz="1300">
+                <a:solidFill>
+                  <a:srgbClr val="F8FAFC"/>
+                </a:solidFill>
+              </a:defRPr>
+            </a:pPr>
+            <a:r>
+              <a:t>• Real-Time CAD 911 Feed Streaming: Kafka event stream ingestion continuously updating hotspot density metrics.</a:t>
+            </a:r>
+          </a:p>
+          <a:p>
+            <a:pPr>
+              <a:defRPr sz="1300">
+                <a:solidFill>
+                  <a:srgbClr val="F8FAFC"/>
+                </a:solidFill>
+              </a:defRPr>
+            </a:pPr>
+            <a:r>
+              <a:t>• Explainable AI (XAI) &amp; Fairness Auditing: Incorporating SHAP and demographic parity checks ensuring bias-free, constitutional predictive policing.</a:t>
+            </a:r>
+          </a:p>
+          <a:p>
+            <a:pPr>
+              <a:defRPr sz="1300">
+                <a:solidFill>
+                  <a:srgbClr val="F8FAFC"/>
+                </a:solidFill>
+              </a:defRPr>
+            </a:pPr>
+            <a:r>
+              <a:t>• Autonomous Drone First Responder: Dispatching autonomous surveillance drones to high-risk zones ahead of squad cars.</a:t>
             </a:r>
           </a:p>
         </p:txBody>
@@ -3230,13 +4840,13 @@
         <p:spPr>
           <a:xfrm>
             <a:off x="0" y="0"/>
-            <a:ext cx="12191695" cy="1097280"/>
+            <a:ext cx="12191695" cy="6858000"/>
           </a:xfrm>
           <a:prstGeom prst="rect">
             <a:avLst/>
           </a:prstGeom>
           <a:solidFill>
-            <a:srgbClr val="0F172A"/>
+            <a:srgbClr val="0A0F1E"/>
           </a:solidFill>
           <a:ln>
             <a:noFill/>
@@ -3272,8 +4882,8 @@
         </p:nvSpPr>
         <p:spPr>
           <a:xfrm>
-            <a:off x="731520" y="137160"/>
-            <a:ext cx="10698480" cy="822960"/>
+            <a:off x="731520" y="365760"/>
+            <a:ext cx="10728655" cy="1005840"/>
           </a:xfrm>
           <a:prstGeom prst="rect">
             <a:avLst/>
@@ -3287,132 +4897,240 @@
           <a:lstStyle/>
           <a:p>
             <a:pPr>
-              <a:defRPr sz="2400" b="1">
-                <a:solidFill>
-                  <a:srgbClr val="FFFFFF"/>
-                </a:solidFill>
-              </a:defRPr>
-            </a:pPr>
-            <a:r>
-              <a:t>1. Background &amp; Industrial Motivation</a:t>
-            </a:r>
-          </a:p>
-          <a:p>
-            <a:pPr>
-              <a:defRPr sz="1100">
-                <a:solidFill>
-                  <a:srgbClr val="94A3B8"/>
-                </a:solidFill>
-              </a:defRPr>
-            </a:pPr>
-            <a:r>
-              <a:t>Academic &amp; Industrial AI Project Series  |  Project 13 of 55</a:t>
-            </a:r>
-          </a:p>
-        </p:txBody>
-      </p:sp>
-      <p:sp>
-        <p:nvSpPr>
-          <p:cNvPr id="4" name="TextBox 3"/>
-          <p:cNvSpPr txBox="1"/>
+              <a:defRPr sz="1100" b="1">
+                <a:solidFill>
+                  <a:srgbClr val="3B82F6"/>
+                </a:solidFill>
+              </a:defRPr>
+            </a:pPr>
+            <a:r>
+              <a:t>PUBLIC SAFETY AI &amp; PREDICTIVE LAW ENFORCEMENT</a:t>
+            </a:r>
+          </a:p>
+          <a:p>
+            <a:pPr>
+              <a:defRPr sz="2200" b="1">
+                <a:solidFill>
+                  <a:srgbClr val="F8FAFC"/>
+                </a:solidFill>
+              </a:defRPr>
+            </a:pPr>
+            <a:r>
+              <a:t>Executive Problem Statement &amp; Law Enforcement Motivation</a:t>
+            </a:r>
+          </a:p>
+        </p:txBody>
+      </p:sp>
+      <p:sp>
+        <p:nvSpPr>
+          <p:cNvPr id="4" name="Rounded Rectangle 3"/>
+          <p:cNvSpPr/>
           <p:nvPr/>
         </p:nvSpPr>
         <p:spPr>
           <a:xfrm>
-            <a:off x="731520" y="1371600"/>
-            <a:ext cx="10698480" cy="5029200"/>
-          </a:xfrm>
-          <a:prstGeom prst="rect">
+            <a:off x="731520" y="1463040"/>
+            <a:ext cx="5120640" cy="4754880"/>
+          </a:xfrm>
+          <a:prstGeom prst="roundRect">
             <a:avLst/>
           </a:prstGeom>
-          <a:noFill/>
-        </p:spPr>
-        <p:txBody>
-          <a:bodyPr wrap="square">
-            <a:spAutoFit/>
-          </a:bodyPr>
-          <a:lstStyle/>
-          <a:p>
-            <a:pPr>
-              <a:defRPr sz="1800" b="1">
-                <a:solidFill>
-                  <a:srgbClr val="1E3A8A"/>
-                </a:solidFill>
-              </a:defRPr>
-            </a:pPr>
-            <a:r>
-              <a:t>Executive Problem Background:</a:t>
-            </a:r>
-          </a:p>
-          <a:p>
-            <a:pPr>
-              <a:spcBef>
-                <a:spcPts val="1000"/>
-              </a:spcBef>
-              <a:defRPr sz="1400">
-                <a:solidFill>
-                  <a:srgbClr val="334155"/>
-                </a:solidFill>
-              </a:defRPr>
-            </a:pPr>
-            <a:r>
-              <a:t>Crime forecasting is one of the most wanted possible forecasts, as it could lead to fewercrimes and fewer police forces to secure threatened areas. However, predicting whenand where crime will happen is challenging. Even modern predictive policing methodsdon’t provide a reasonable or accurate approximation to forecast crimes. It has a longhistory of experiments and tests to reduce and to prevent crime. Deep Learning is arelatively new machine learning topic, which achieved state-of-the-art perfo...</a:t>
-            </a:r>
-          </a:p>
-          <a:p>
-            <a:pPr>
-              <a:spcBef>
-                <a:spcPts val="1400"/>
-              </a:spcBef>
-              <a:defRPr sz="1600" b="1"/>
-            </a:pPr>
-            <a:r>
-              <a:t>Core Industry Drivers:</a:t>
-            </a:r>
-          </a:p>
-          <a:p>
-            <a:pPr>
-              <a:spcBef>
-                <a:spcPts val="400"/>
-              </a:spcBef>
+          <a:solidFill>
+            <a:srgbClr val="141B2D"/>
+          </a:solidFill>
+          <a:ln>
+            <a:noFill/>
+          </a:ln>
+        </p:spPr>
+        <p:style>
+          <a:lnRef idx="1">
+            <a:schemeClr val="accent1"/>
+          </a:lnRef>
+          <a:fillRef idx="3">
+            <a:schemeClr val="accent1"/>
+          </a:fillRef>
+          <a:effectRef idx="2">
+            <a:schemeClr val="accent1"/>
+          </a:effectRef>
+          <a:fontRef idx="minor">
+            <a:schemeClr val="lt1"/>
+          </a:fontRef>
+        </p:style>
+        <p:txBody>
+          <a:bodyPr rtlCol="0" anchor="ctr" wrap="square"/>
+          <a:lstStyle/>
+          <a:p>
+            <a:pPr algn="ctr">
+              <a:defRPr b="1" sz="1800">
+                <a:solidFill>
+                  <a:srgbClr val="EF4444"/>
+                </a:solidFill>
+              </a:defRPr>
+            </a:pPr>
+            <a:r>
+              <a:t>Challenges in Modern Policing</a:t>
+            </a:r>
+          </a:p>
+          <a:p>
+            <a:br/>
+            <a:pPr>
               <a:defRPr sz="1300">
                 <a:solidFill>
-                  <a:srgbClr val="475569"/>
-                </a:solidFill>
-              </a:defRPr>
-            </a:pPr>
-            <a:r>
-              <a:t>• Manual legacy inspection/decision methods incur high operational costs, delay, and human error.</a:t>
-            </a:r>
-          </a:p>
-          <a:p>
-            <a:pPr>
-              <a:spcBef>
-                <a:spcPts val="400"/>
-              </a:spcBef>
+                  <a:srgbClr val="F8FAFC"/>
+                </a:solidFill>
+              </a:defRPr>
+            </a:pPr>
+            <a:r>
+              <a:t>• Reactive vs Proactive Policing: Traditional law enforcement relies predominantly on emergency 911 calls after an offense has already occurred, leading to delayed response times.</a:t>
+            </a:r>
+          </a:p>
+          <a:p>
+            <a:pPr>
               <a:defRPr sz="1300">
                 <a:solidFill>
-                  <a:srgbClr val="475569"/>
-                </a:solidFill>
-              </a:defRPr>
-            </a:pPr>
-            <a:r>
-              <a:t>• Scalable automated solutions require low-latency edge and cloud neural network inference.</a:t>
-            </a:r>
-          </a:p>
-          <a:p>
-            <a:pPr>
-              <a:spcBef>
-                <a:spcPts val="400"/>
-              </a:spcBef>
+                  <a:srgbClr val="F8FAFC"/>
+                </a:solidFill>
+              </a:defRPr>
+            </a:pPr>
+            <a:r>
+              <a:t>• High Resource Constraints: Urban police departments face limited patrol units and staffing shortages, making random uniform street patrols inefficient and costly.</a:t>
+            </a:r>
+          </a:p>
+          <a:p>
+            <a:pPr>
               <a:defRPr sz="1300">
                 <a:solidFill>
-                  <a:srgbClr val="475569"/>
-                </a:solidFill>
-              </a:defRPr>
-            </a:pPr>
-            <a:r>
-              <a:t>• Explainable prediction confidence metrics are essential for operational trust and regulatory compliance.</a:t>
+                  <a:srgbClr val="F8FAFC"/>
+                </a:solidFill>
+              </a:defRPr>
+            </a:pPr>
+            <a:r>
+              <a:t>• Complex Spatio-Temporal Dynamics: Crime rates fluctuate dramatically based on hour of day, day of week, commercial density, ambient lighting, and environmental factors.</a:t>
+            </a:r>
+          </a:p>
+          <a:p>
+            <a:pPr>
+              <a:defRPr sz="1300">
+                <a:solidFill>
+                  <a:srgbClr val="F8FAFC"/>
+                </a:solidFill>
+              </a:defRPr>
+            </a:pPr>
+            <a:r>
+              <a:t>• Need for Empirical Forecasting: Municipalities require quantitative AI forecasting to strategically pre-position patrol vehicles into high-risk sectors before crimes occur.</a:t>
+            </a:r>
+          </a:p>
+        </p:txBody>
+      </p:sp>
+      <p:sp>
+        <p:nvSpPr>
+          <p:cNvPr id="5" name="Rounded Rectangle 4"/>
+          <p:cNvSpPr/>
+          <p:nvPr/>
+        </p:nvSpPr>
+        <p:spPr>
+          <a:xfrm>
+            <a:off x="6217920" y="1463040"/>
+            <a:ext cx="5212080" cy="4754880"/>
+          </a:xfrm>
+          <a:prstGeom prst="roundRect">
+            <a:avLst/>
+          </a:prstGeom>
+          <a:solidFill>
+            <a:srgbClr val="141B2D"/>
+          </a:solidFill>
+          <a:ln>
+            <a:noFill/>
+          </a:ln>
+        </p:spPr>
+        <p:style>
+          <a:lnRef idx="1">
+            <a:schemeClr val="accent1"/>
+          </a:lnRef>
+          <a:fillRef idx="3">
+            <a:schemeClr val="accent1"/>
+          </a:fillRef>
+          <a:effectRef idx="2">
+            <a:schemeClr val="accent1"/>
+          </a:effectRef>
+          <a:fontRef idx="minor">
+            <a:schemeClr val="lt1"/>
+          </a:fontRef>
+        </p:style>
+        <p:txBody>
+          <a:bodyPr rtlCol="0" anchor="ctr" wrap="square"/>
+          <a:lstStyle/>
+          <a:p>
+            <a:pPr algn="ctr">
+              <a:defRPr b="1" sz="1800">
+                <a:solidFill>
+                  <a:srgbClr val="3B82F6"/>
+                </a:solidFill>
+              </a:defRPr>
+            </a:pPr>
+            <a:r>
+              <a:t>Core Technical Objectives</a:t>
+            </a:r>
+          </a:p>
+          <a:p>
+            <a:br/>
+            <a:pPr>
+              <a:defRPr sz="1300">
+                <a:solidFill>
+                  <a:srgbClr val="F8FAFC"/>
+                </a:solidFill>
+              </a:defRPr>
+            </a:pPr>
+            <a:r>
+              <a:t>• 11-Dimensional Spatio-Temporal Modeling: Ingests spatial coordinates, police district, location type, temporal time flags, historical density, ambient light, and patrol presence.</a:t>
+            </a:r>
+          </a:p>
+          <a:p>
+            <a:pPr>
+              <a:defRPr sz="1300">
+                <a:solidFill>
+                  <a:srgbClr val="F8FAFC"/>
+                </a:solidFill>
+              </a:defRPr>
+            </a:pPr>
+            <a:r>
+              <a:t>• Deep Neural Network Risk Forecasting: PyTorch DNN predicting 4-tier threat levels (LOW, MODERATE, HIGH, CRITICAL) with calibrated softmax probabilities.</a:t>
+            </a:r>
+          </a:p>
+          <a:p>
+            <a:pPr>
+              <a:defRPr sz="1300">
+                <a:solidFill>
+                  <a:srgbClr val="F8FAFC"/>
+                </a:solidFill>
+              </a:defRPr>
+            </a:pPr>
+            <a:r>
+              <a:t>• Ensemble Crime Type Classification: Random Forest classifier identifying exact offense category (ROBBERY, BATTERY, THEFT, BURGLARY, etc.).</a:t>
+            </a:r>
+          </a:p>
+          <a:p>
+            <a:pPr>
+              <a:defRPr sz="1300">
+                <a:solidFill>
+                  <a:srgbClr val="F8FAFC"/>
+                </a:solidFill>
+              </a:defRPr>
+            </a:pPr>
+            <a:r>
+              <a:t>• 24-Hour Predictive Hourly Curves: Continuously computes hourly spike probability curves to optimize patrol shift scheduling.</a:t>
+            </a:r>
+          </a:p>
+          <a:p>
+            <a:pPr>
+              <a:defRPr sz="1300">
+                <a:solidFill>
+                  <a:srgbClr val="F8FAFC"/>
+                </a:solidFill>
+              </a:defRPr>
+            </a:pPr>
+            <a:r>
+              <a:t>• Automated Tactical Patrol Dispatch: Persistent SQLite ledger logging incidents and routing squad cars with priority codes.</a:t>
             </a:r>
           </a:p>
         </p:txBody>
@@ -3444,13 +5162,13 @@
         <p:spPr>
           <a:xfrm>
             <a:off x="0" y="0"/>
-            <a:ext cx="12191695" cy="1097280"/>
+            <a:ext cx="12191695" cy="6858000"/>
           </a:xfrm>
           <a:prstGeom prst="rect">
             <a:avLst/>
           </a:prstGeom>
           <a:solidFill>
-            <a:srgbClr val="0F172A"/>
+            <a:srgbClr val="0A0F1E"/>
           </a:solidFill>
           <a:ln>
             <a:noFill/>
@@ -3486,8 +5204,8 @@
         </p:nvSpPr>
         <p:spPr>
           <a:xfrm>
-            <a:off x="731520" y="137160"/>
-            <a:ext cx="10698480" cy="822960"/>
+            <a:off x="731520" y="365760"/>
+            <a:ext cx="10728655" cy="1005840"/>
           </a:xfrm>
           <a:prstGeom prst="rect">
             <a:avLst/>
@@ -3501,169 +5219,361 @@
           <a:lstStyle/>
           <a:p>
             <a:pPr>
-              <a:defRPr sz="2400" b="1">
-                <a:solidFill>
-                  <a:srgbClr val="FFFFFF"/>
-                </a:solidFill>
-              </a:defRPr>
-            </a:pPr>
-            <a:r>
-              <a:t>2. Problem Statement &amp; Key Objectives</a:t>
-            </a:r>
-          </a:p>
-          <a:p>
-            <a:pPr>
-              <a:defRPr sz="1100">
-                <a:solidFill>
-                  <a:srgbClr val="94A3B8"/>
-                </a:solidFill>
-              </a:defRPr>
-            </a:pPr>
-            <a:r>
-              <a:t>Academic &amp; Industrial AI Project Series  |  Project 13 of 55</a:t>
-            </a:r>
-          </a:p>
-        </p:txBody>
-      </p:sp>
-      <p:sp>
-        <p:nvSpPr>
-          <p:cNvPr id="4" name="TextBox 3"/>
-          <p:cNvSpPr txBox="1"/>
+              <a:defRPr sz="1100" b="1">
+                <a:solidFill>
+                  <a:srgbClr val="3B82F6"/>
+                </a:solidFill>
+              </a:defRPr>
+            </a:pPr>
+            <a:r>
+              <a:t>PUBLIC SAFETY AI &amp; PREDICTIVE LAW ENFORCEMENT</a:t>
+            </a:r>
+          </a:p>
+          <a:p>
+            <a:pPr>
+              <a:defRPr sz="2200" b="1">
+                <a:solidFill>
+                  <a:srgbClr val="F8FAFC"/>
+                </a:solidFill>
+              </a:defRPr>
+            </a:pPr>
+            <a:r>
+              <a:t>End-to-End System Architecture &amp; Microservice Pipeline</a:t>
+            </a:r>
+          </a:p>
+        </p:txBody>
+      </p:sp>
+      <p:sp>
+        <p:nvSpPr>
+          <p:cNvPr id="4" name="Rounded Rectangle 3"/>
+          <p:cNvSpPr/>
           <p:nvPr/>
         </p:nvSpPr>
         <p:spPr>
           <a:xfrm>
-            <a:off x="731520" y="1371600"/>
-            <a:ext cx="10698480" cy="5029200"/>
-          </a:xfrm>
-          <a:prstGeom prst="rect">
+            <a:off x="731520" y="1645920"/>
+            <a:ext cx="2011680" cy="4572000"/>
+          </a:xfrm>
+          <a:prstGeom prst="roundRect">
             <a:avLst/>
           </a:prstGeom>
-          <a:noFill/>
-        </p:spPr>
-        <p:txBody>
-          <a:bodyPr wrap="square">
-            <a:spAutoFit/>
-          </a:bodyPr>
-          <a:lstStyle/>
-          <a:p>
-            <a:pPr>
-              <a:spcBef>
-                <a:spcPts val="800"/>
-              </a:spcBef>
-              <a:defRPr sz="1600" b="1">
+          <a:solidFill>
+            <a:srgbClr val="141B2D"/>
+          </a:solidFill>
+          <a:ln w="19050">
+            <a:solidFill>
+              <a:srgbClr val="3B82F6"/>
+            </a:solidFill>
+          </a:ln>
+        </p:spPr>
+        <p:style>
+          <a:lnRef idx="1">
+            <a:schemeClr val="accent1"/>
+          </a:lnRef>
+          <a:fillRef idx="3">
+            <a:schemeClr val="accent1"/>
+          </a:fillRef>
+          <a:effectRef idx="2">
+            <a:schemeClr val="accent1"/>
+          </a:effectRef>
+          <a:fontRef idx="minor">
+            <a:schemeClr val="lt1"/>
+          </a:fontRef>
+        </p:style>
+        <p:txBody>
+          <a:bodyPr rtlCol="0" anchor="ctr" wrap="square"/>
+          <a:lstStyle/>
+          <a:p>
+            <a:pPr algn="ctr">
+              <a:defRPr b="1" sz="1400">
+                <a:solidFill>
+                  <a:srgbClr val="3B82F6"/>
+                </a:solidFill>
+              </a:defRPr>
+            </a:pPr>
+            <a:r>
+              <a:t>1. Data Ingestion</a:t>
+            </a:r>
+          </a:p>
+          <a:p>
+            <a:br/>
+            <a:pPr>
+              <a:defRPr sz="1200">
+                <a:solidFill>
+                  <a:srgbClr val="F8FAFC"/>
+                </a:solidFill>
+              </a:defRPr>
+            </a:pPr>
+            <a:r>
+              <a:t>5,000 urban incident corpus with coordinates, districts, and temporal timestamps.</a:t>
+            </a:r>
+          </a:p>
+        </p:txBody>
+      </p:sp>
+      <p:sp>
+        <p:nvSpPr>
+          <p:cNvPr id="5" name="Rounded Rectangle 4"/>
+          <p:cNvSpPr/>
+          <p:nvPr/>
+        </p:nvSpPr>
+        <p:spPr>
+          <a:xfrm>
+            <a:off x="2880360" y="1645920"/>
+            <a:ext cx="2011680" cy="4572000"/>
+          </a:xfrm>
+          <a:prstGeom prst="roundRect">
+            <a:avLst/>
+          </a:prstGeom>
+          <a:solidFill>
+            <a:srgbClr val="141B2D"/>
+          </a:solidFill>
+          <a:ln w="19050">
+            <a:solidFill>
+              <a:srgbClr val="F59E0B"/>
+            </a:solidFill>
+          </a:ln>
+        </p:spPr>
+        <p:style>
+          <a:lnRef idx="1">
+            <a:schemeClr val="accent1"/>
+          </a:lnRef>
+          <a:fillRef idx="3">
+            <a:schemeClr val="accent1"/>
+          </a:fillRef>
+          <a:effectRef idx="2">
+            <a:schemeClr val="accent1"/>
+          </a:effectRef>
+          <a:fontRef idx="minor">
+            <a:schemeClr val="lt1"/>
+          </a:fontRef>
+        </p:style>
+        <p:txBody>
+          <a:bodyPr rtlCol="0" anchor="ctr" wrap="square"/>
+          <a:lstStyle/>
+          <a:p>
+            <a:pPr algn="ctr">
+              <a:defRPr b="1" sz="1400">
+                <a:solidFill>
+                  <a:srgbClr val="F59E0B"/>
+                </a:solidFill>
+              </a:defRPr>
+            </a:pPr>
+            <a:r>
+              <a:t>2. Feature Pipeline</a:t>
+            </a:r>
+          </a:p>
+          <a:p>
+            <a:br/>
+            <a:pPr>
+              <a:defRPr sz="1200">
+                <a:solidFill>
+                  <a:srgbClr val="F8FAFC"/>
+                </a:solidFill>
+              </a:defRPr>
+            </a:pPr>
+            <a:r>
+              <a:t>StandardScaler normalization &amp; categorical label encoders mapping 11 feature dimensions.</a:t>
+            </a:r>
+          </a:p>
+        </p:txBody>
+      </p:sp>
+      <p:sp>
+        <p:nvSpPr>
+          <p:cNvPr id="6" name="Rounded Rectangle 5"/>
+          <p:cNvSpPr/>
+          <p:nvPr/>
+        </p:nvSpPr>
+        <p:spPr>
+          <a:xfrm>
+            <a:off x="5029200" y="1645920"/>
+            <a:ext cx="2011680" cy="4572000"/>
+          </a:xfrm>
+          <a:prstGeom prst="roundRect">
+            <a:avLst/>
+          </a:prstGeom>
+          <a:solidFill>
+            <a:srgbClr val="141B2D"/>
+          </a:solidFill>
+          <a:ln w="19050">
+            <a:solidFill>
+              <a:srgbClr val="EF4444"/>
+            </a:solidFill>
+          </a:ln>
+        </p:spPr>
+        <p:style>
+          <a:lnRef idx="1">
+            <a:schemeClr val="accent1"/>
+          </a:lnRef>
+          <a:fillRef idx="3">
+            <a:schemeClr val="accent1"/>
+          </a:fillRef>
+          <a:effectRef idx="2">
+            <a:schemeClr val="accent1"/>
+          </a:effectRef>
+          <a:fontRef idx="minor">
+            <a:schemeClr val="lt1"/>
+          </a:fontRef>
+        </p:style>
+        <p:txBody>
+          <a:bodyPr rtlCol="0" anchor="ctr" wrap="square"/>
+          <a:lstStyle/>
+          <a:p>
+            <a:pPr algn="ctr">
+              <a:defRPr b="1" sz="1400">
+                <a:solidFill>
+                  <a:srgbClr val="EF4444"/>
+                </a:solidFill>
+              </a:defRPr>
+            </a:pPr>
+            <a:r>
+              <a:t>3. PyTorch DNN</a:t>
+            </a:r>
+          </a:p>
+          <a:p>
+            <a:br/>
+            <a:pPr>
+              <a:defRPr sz="1200">
+                <a:solidFill>
+                  <a:srgbClr val="F8FAFC"/>
+                </a:solidFill>
+              </a:defRPr>
+            </a:pPr>
+            <a:r>
+              <a:t>Multi-layer dense network with BatchNorm &amp; Dropout predicting 4-tier threat levels.</a:t>
+            </a:r>
+          </a:p>
+        </p:txBody>
+      </p:sp>
+      <p:sp>
+        <p:nvSpPr>
+          <p:cNvPr id="7" name="Rounded Rectangle 6"/>
+          <p:cNvSpPr/>
+          <p:nvPr/>
+        </p:nvSpPr>
+        <p:spPr>
+          <a:xfrm>
+            <a:off x="7178040" y="1645920"/>
+            <a:ext cx="2011680" cy="4572000"/>
+          </a:xfrm>
+          <a:prstGeom prst="roundRect">
+            <a:avLst/>
+          </a:prstGeom>
+          <a:solidFill>
+            <a:srgbClr val="141B2D"/>
+          </a:solidFill>
+          <a:ln w="19050">
+            <a:solidFill>
+              <a:srgbClr val="10B981"/>
+            </a:solidFill>
+          </a:ln>
+        </p:spPr>
+        <p:style>
+          <a:lnRef idx="1">
+            <a:schemeClr val="accent1"/>
+          </a:lnRef>
+          <a:fillRef idx="3">
+            <a:schemeClr val="accent1"/>
+          </a:fillRef>
+          <a:effectRef idx="2">
+            <a:schemeClr val="accent1"/>
+          </a:effectRef>
+          <a:fontRef idx="minor">
+            <a:schemeClr val="lt1"/>
+          </a:fontRef>
+        </p:style>
+        <p:txBody>
+          <a:bodyPr rtlCol="0" anchor="ctr" wrap="square"/>
+          <a:lstStyle/>
+          <a:p>
+            <a:pPr algn="ctr">
+              <a:defRPr b="1" sz="1400">
                 <a:solidFill>
                   <a:srgbClr val="10B981"/>
                 </a:solidFill>
               </a:defRPr>
             </a:pPr>
             <a:r>
-              <a:t>✓ Predictive Accuracy &amp; Generalization</a:t>
-            </a:r>
-          </a:p>
-          <a:p>
-            <a:pPr>
-              <a:spcBef>
-                <a:spcPts val="200"/>
-              </a:spcBef>
-              <a:defRPr sz="1300">
-                <a:solidFill>
-                  <a:srgbClr val="475569"/>
-                </a:solidFill>
-              </a:defRPr>
-            </a:pPr>
-            <a:r>
-              <a:t>Achieve high validation precision across diverse real-world operating distributions.</a:t>
-            </a:r>
-          </a:p>
-          <a:p>
-            <a:pPr>
-              <a:spcBef>
-                <a:spcPts val="800"/>
-              </a:spcBef>
-              <a:defRPr sz="1600" b="1">
-                <a:solidFill>
-                  <a:srgbClr val="10B981"/>
-                </a:solidFill>
-              </a:defRPr>
-            </a:pPr>
-            <a:r>
-              <a:t>✓ Real-Time Low Latency Inference</a:t>
-            </a:r>
-          </a:p>
-          <a:p>
-            <a:pPr>
-              <a:spcBef>
-                <a:spcPts val="200"/>
-              </a:spcBef>
-              <a:defRPr sz="1300">
-                <a:solidFill>
-                  <a:srgbClr val="475569"/>
-                </a:solidFill>
-              </a:defRPr>
-            </a:pPr>
-            <a:r>
-              <a:t>Deliver end-to-end processing response times under 35 milliseconds per query.</a:t>
-            </a:r>
-          </a:p>
-          <a:p>
-            <a:pPr>
-              <a:spcBef>
-                <a:spcPts val="800"/>
-              </a:spcBef>
-              <a:defRPr sz="1600" b="1">
-                <a:solidFill>
-                  <a:srgbClr val="10B981"/>
-                </a:solidFill>
-              </a:defRPr>
-            </a:pPr>
-            <a:r>
-              <a:t>✓ Robust Anomaly &amp; Boundary Handling</a:t>
-            </a:r>
-          </a:p>
-          <a:p>
-            <a:pPr>
-              <a:spcBef>
-                <a:spcPts val="200"/>
-              </a:spcBef>
-              <a:defRPr sz="1300">
-                <a:solidFill>
-                  <a:srgbClr val="475569"/>
-                </a:solidFill>
-              </a:defRPr>
-            </a:pPr>
-            <a:r>
-              <a:t>Detect out-of-distribution instances and reject anomalous inputs with deterministic alerts.</a:t>
-            </a:r>
-          </a:p>
-          <a:p>
-            <a:pPr>
-              <a:spcBef>
-                <a:spcPts val="800"/>
-              </a:spcBef>
-              <a:defRPr sz="1600" b="1">
-                <a:solidFill>
-                  <a:srgbClr val="10B981"/>
-                </a:solidFill>
-              </a:defRPr>
-            </a:pPr>
-            <a:r>
-              <a:t>✓ Production-Ready Full Stack</a:t>
-            </a:r>
-          </a:p>
-          <a:p>
-            <a:pPr>
-              <a:spcBef>
-                <a:spcPts val="200"/>
-              </a:spcBef>
-              <a:defRPr sz="1300">
-                <a:solidFill>
-                  <a:srgbClr val="475569"/>
-                </a:solidFill>
-              </a:defRPr>
-            </a:pPr>
-            <a:r>
-              <a:t>Provide modular REST APIs, audit logging, and responsive user interfaces.</a:t>
+              <a:t>4. RF Classifier</a:t>
+            </a:r>
+          </a:p>
+          <a:p>
+            <a:br/>
+            <a:pPr>
+              <a:defRPr sz="1200">
+                <a:solidFill>
+                  <a:srgbClr val="F8FAFC"/>
+                </a:solidFill>
+              </a:defRPr>
+            </a:pPr>
+            <a:r>
+              <a:t>150-tree Random Forest ensemble isolating primary crime category.</a:t>
+            </a:r>
+          </a:p>
+        </p:txBody>
+      </p:sp>
+      <p:sp>
+        <p:nvSpPr>
+          <p:cNvPr id="8" name="Rounded Rectangle 7"/>
+          <p:cNvSpPr/>
+          <p:nvPr/>
+        </p:nvSpPr>
+        <p:spPr>
+          <a:xfrm>
+            <a:off x="9326880" y="1645920"/>
+            <a:ext cx="2011680" cy="4572000"/>
+          </a:xfrm>
+          <a:prstGeom prst="roundRect">
+            <a:avLst/>
+          </a:prstGeom>
+          <a:solidFill>
+            <a:srgbClr val="141B2D"/>
+          </a:solidFill>
+          <a:ln w="19050">
+            <a:solidFill>
+              <a:srgbClr val="F8FAFC"/>
+            </a:solidFill>
+          </a:ln>
+        </p:spPr>
+        <p:style>
+          <a:lnRef idx="1">
+            <a:schemeClr val="accent1"/>
+          </a:lnRef>
+          <a:fillRef idx="3">
+            <a:schemeClr val="accent1"/>
+          </a:fillRef>
+          <a:effectRef idx="2">
+            <a:schemeClr val="accent1"/>
+          </a:effectRef>
+          <a:fontRef idx="minor">
+            <a:schemeClr val="lt1"/>
+          </a:fontRef>
+        </p:style>
+        <p:txBody>
+          <a:bodyPr rtlCol="0" anchor="ctr" wrap="square"/>
+          <a:lstStyle/>
+          <a:p>
+            <a:pPr algn="ctr">
+              <a:defRPr b="1" sz="1400">
+                <a:solidFill>
+                  <a:srgbClr val="F8FAFC"/>
+                </a:solidFill>
+              </a:defRPr>
+            </a:pPr>
+            <a:r>
+              <a:t>5. SQLite DB &amp; UI</a:t>
+            </a:r>
+          </a:p>
+          <a:p>
+            <a:br/>
+            <a:pPr>
+              <a:defRPr sz="1200">
+                <a:solidFill>
+                  <a:srgbClr val="F8FAFC"/>
+                </a:solidFill>
+              </a:defRPr>
+            </a:pPr>
+            <a:r>
+              <a:t>Persistent ledger logging dispatches on Port 5013 with glassmorphic dashboard.</a:t>
             </a:r>
           </a:p>
         </p:txBody>
@@ -3695,13 +5605,13 @@
         <p:spPr>
           <a:xfrm>
             <a:off x="0" y="0"/>
-            <a:ext cx="12191695" cy="1097280"/>
+            <a:ext cx="12191695" cy="6858000"/>
           </a:xfrm>
           <a:prstGeom prst="rect">
             <a:avLst/>
           </a:prstGeom>
           <a:solidFill>
-            <a:srgbClr val="0F172A"/>
+            <a:srgbClr val="0A0F1E"/>
           </a:solidFill>
           <a:ln>
             <a:noFill/>
@@ -3737,8 +5647,8 @@
         </p:nvSpPr>
         <p:spPr>
           <a:xfrm>
-            <a:off x="731520" y="137160"/>
-            <a:ext cx="10698480" cy="822960"/>
+            <a:off x="731520" y="365760"/>
+            <a:ext cx="10728655" cy="1005840"/>
           </a:xfrm>
           <a:prstGeom prst="rect">
             <a:avLst/>
@@ -3752,184 +5662,268 @@
           <a:lstStyle/>
           <a:p>
             <a:pPr>
-              <a:defRPr sz="2400" b="1">
-                <a:solidFill>
-                  <a:srgbClr val="FFFFFF"/>
-                </a:solidFill>
-              </a:defRPr>
-            </a:pPr>
-            <a:r>
-              <a:t>3. System Architecture &amp; Workflow Pipeline</a:t>
-            </a:r>
-          </a:p>
-          <a:p>
-            <a:pPr>
-              <a:defRPr sz="1100">
-                <a:solidFill>
-                  <a:srgbClr val="94A3B8"/>
-                </a:solidFill>
-              </a:defRPr>
-            </a:pPr>
-            <a:r>
-              <a:t>Academic &amp; Industrial AI Project Series  |  Project 13 of 55</a:t>
-            </a:r>
-          </a:p>
-        </p:txBody>
-      </p:sp>
-      <p:sp>
-        <p:nvSpPr>
-          <p:cNvPr id="4" name="TextBox 3"/>
-          <p:cNvSpPr txBox="1"/>
+              <a:defRPr sz="1100" b="1">
+                <a:solidFill>
+                  <a:srgbClr val="3B82F6"/>
+                </a:solidFill>
+              </a:defRPr>
+            </a:pPr>
+            <a:r>
+              <a:t>PUBLIC SAFETY AI &amp; PREDICTIVE LAW ENFORCEMENT</a:t>
+            </a:r>
+          </a:p>
+          <a:p>
+            <a:pPr>
+              <a:defRPr sz="2200" b="1">
+                <a:solidFill>
+                  <a:srgbClr val="F8FAFC"/>
+                </a:solidFill>
+              </a:defRPr>
+            </a:pPr>
+            <a:r>
+              <a:t>Deep Neural Network Architecture (CrimeRiskDNN)</a:t>
+            </a:r>
+          </a:p>
+        </p:txBody>
+      </p:sp>
+      <p:sp>
+        <p:nvSpPr>
+          <p:cNvPr id="4" name="Rounded Rectangle 3"/>
+          <p:cNvSpPr/>
           <p:nvPr/>
         </p:nvSpPr>
         <p:spPr>
           <a:xfrm>
-            <a:off x="731520" y="1371600"/>
-            <a:ext cx="10698480" cy="5029200"/>
-          </a:xfrm>
-          <a:prstGeom prst="rect">
+            <a:off x="731520" y="1463040"/>
+            <a:ext cx="5120640" cy="4754880"/>
+          </a:xfrm>
+          <a:prstGeom prst="roundRect">
             <a:avLst/>
           </a:prstGeom>
-          <a:noFill/>
-        </p:spPr>
-        <p:txBody>
-          <a:bodyPr wrap="square">
-            <a:spAutoFit/>
-          </a:bodyPr>
-          <a:lstStyle/>
-          <a:p>
-            <a:pPr>
-              <a:spcBef>
-                <a:spcPts val="800"/>
-              </a:spcBef>
-              <a:defRPr sz="1500" b="1">
-                <a:solidFill>
-                  <a:srgbClr val="2563EB"/>
-                </a:solidFill>
-              </a:defRPr>
-            </a:pPr>
-            <a:r>
-              <a:t>[1] Ingestion Layer</a:t>
-            </a:r>
-          </a:p>
-          <a:p>
+          <a:solidFill>
+            <a:srgbClr val="141B2D"/>
+          </a:solidFill>
+          <a:ln>
+            <a:noFill/>
+          </a:ln>
+        </p:spPr>
+        <p:style>
+          <a:lnRef idx="1">
+            <a:schemeClr val="accent1"/>
+          </a:lnRef>
+          <a:fillRef idx="3">
+            <a:schemeClr val="accent1"/>
+          </a:fillRef>
+          <a:effectRef idx="2">
+            <a:schemeClr val="accent1"/>
+          </a:effectRef>
+          <a:fontRef idx="minor">
+            <a:schemeClr val="lt1"/>
+          </a:fontRef>
+        </p:style>
+        <p:txBody>
+          <a:bodyPr rtlCol="0" anchor="ctr" wrap="square"/>
+          <a:lstStyle/>
+          <a:p>
+            <a:pPr algn="ctr">
+              <a:defRPr b="1" sz="1700">
+                <a:solidFill>
+                  <a:srgbClr val="3B82F6"/>
+                </a:solidFill>
+              </a:defRPr>
+            </a:pPr>
+            <a:r>
+              <a:t>Network Topology &amp; Regularization</a:t>
+            </a:r>
+          </a:p>
+          <a:p>
+            <a:br/>
             <a:pPr>
               <a:defRPr sz="1300">
                 <a:solidFill>
-                  <a:srgbClr val="475569"/>
-                </a:solidFill>
-              </a:defRPr>
-            </a:pPr>
-            <a:r>
-              <a:t>Raw telemetry, video feeds, or structured tabular features ingested via secure endpoints.</a:t>
-            </a:r>
-          </a:p>
-          <a:p>
-            <a:pPr>
-              <a:spcBef>
-                <a:spcPts val="800"/>
-              </a:spcBef>
-              <a:defRPr sz="1500" b="1">
-                <a:solidFill>
-                  <a:srgbClr val="2563EB"/>
-                </a:solidFill>
-              </a:defRPr>
-            </a:pPr>
-            <a:r>
-              <a:t>[2] Preprocessing &amp; Normalization</a:t>
+                  <a:srgbClr val="F8FAFC"/>
+                </a:solidFill>
+              </a:defRPr>
+            </a:pPr>
+            <a:r>
+              <a:t>• Input Dimension (d = 11): Normalized vector of temporal, environmental, and spatial attributes.</a:t>
             </a:r>
           </a:p>
           <a:p>
             <a:pPr>
               <a:defRPr sz="1300">
                 <a:solidFill>
-                  <a:srgbClr val="475569"/>
-                </a:solidFill>
-              </a:defRPr>
-            </a:pPr>
-            <a:r>
-              <a:t>Feature scaling, missing value imputation, winsorization, and tensor reshaping.</a:t>
-            </a:r>
-          </a:p>
-          <a:p>
-            <a:pPr>
-              <a:spcBef>
-                <a:spcPts val="800"/>
-              </a:spcBef>
-              <a:defRPr sz="1500" b="1">
-                <a:solidFill>
-                  <a:srgbClr val="2563EB"/>
-                </a:solidFill>
-              </a:defRPr>
-            </a:pPr>
-            <a:r>
-              <a:t>[3] Deep Neural Inference Engine</a:t>
+                  <a:srgbClr val="F8FAFC"/>
+                </a:solidFill>
+              </a:defRPr>
+            </a:pPr>
+            <a:r>
+              <a:t>• Dense Layer 1: 11 -&gt; 128 hidden units, followed by BatchNorm1d, ReLU activation, and Dropout (p = 0.25).</a:t>
             </a:r>
           </a:p>
           <a:p>
             <a:pPr>
               <a:defRPr sz="1300">
                 <a:solidFill>
-                  <a:srgbClr val="475569"/>
-                </a:solidFill>
-              </a:defRPr>
-            </a:pPr>
-            <a:r>
-              <a:t>Optimized model evaluating representations with GPU/MPS/CPU acceleration.</a:t>
-            </a:r>
-          </a:p>
-          <a:p>
-            <a:pPr>
-              <a:spcBef>
-                <a:spcPts val="800"/>
-              </a:spcBef>
-              <a:defRPr sz="1500" b="1">
-                <a:solidFill>
-                  <a:srgbClr val="2563EB"/>
-                </a:solidFill>
-              </a:defRPr>
-            </a:pPr>
-            <a:r>
-              <a:t>[4] Post-Processing &amp; Decision Support</a:t>
+                  <a:srgbClr val="F8FAFC"/>
+                </a:solidFill>
+              </a:defRPr>
+            </a:pPr>
+            <a:r>
+              <a:t>• Dense Layer 2: 128 -&gt; 64 hidden units, BatchNorm1d, ReLU activation, and Dropout (p = 0.20).</a:t>
             </a:r>
           </a:p>
           <a:p>
             <a:pPr>
               <a:defRPr sz="1300">
                 <a:solidFill>
-                  <a:srgbClr val="475569"/>
-                </a:solidFill>
-              </a:defRPr>
-            </a:pPr>
-            <a:r>
-              <a:t>Threshold calibration, confidence scoring, classification/regression output formatting.</a:t>
-            </a:r>
-          </a:p>
-          <a:p>
-            <a:pPr>
-              <a:spcBef>
-                <a:spcPts val="800"/>
-              </a:spcBef>
-              <a:defRPr sz="1500" b="1">
-                <a:solidFill>
-                  <a:srgbClr val="2563EB"/>
-                </a:solidFill>
-              </a:defRPr>
-            </a:pPr>
-            <a:r>
-              <a:t>[5] Visualization &amp; Persistence</a:t>
+                  <a:srgbClr val="F8FAFC"/>
+                </a:solidFill>
+              </a:defRPr>
+            </a:pPr>
+            <a:r>
+              <a:t>• Dense Layer 3: 64 -&gt; 32 hidden units with non-linear ReLU gating.</a:t>
             </a:r>
           </a:p>
           <a:p>
             <a:pPr>
               <a:defRPr sz="1300">
                 <a:solidFill>
-                  <a:srgbClr val="475569"/>
-                </a:solidFill>
-              </a:defRPr>
-            </a:pPr>
-            <a:r>
-              <a:t>Interactive UI dashboard rendering metrics and SQLite/PostgreSQL audit logging.</a:t>
+                  <a:srgbClr val="F8FAFC"/>
+                </a:solidFill>
+              </a:defRPr>
+            </a:pPr>
+            <a:r>
+              <a:t>• Classification Head: 32 -&gt; 4 logits corresponding to threat classes [CRITICAL, HIGH, LOW, MODERATE].</a:t>
+            </a:r>
+          </a:p>
+          <a:p>
+            <a:pPr>
+              <a:defRPr sz="1300">
+                <a:solidFill>
+                  <a:srgbClr val="F8FAFC"/>
+                </a:solidFill>
+              </a:defRPr>
+            </a:pPr>
+            <a:r>
+              <a:t>• Softmax Normalization: Yields mathematically calibrated probability distribution over threat categories.</a:t>
+            </a:r>
+          </a:p>
+        </p:txBody>
+      </p:sp>
+      <p:sp>
+        <p:nvSpPr>
+          <p:cNvPr id="5" name="Rounded Rectangle 4"/>
+          <p:cNvSpPr/>
+          <p:nvPr/>
+        </p:nvSpPr>
+        <p:spPr>
+          <a:xfrm>
+            <a:off x="6217920" y="1463040"/>
+            <a:ext cx="5212080" cy="4754880"/>
+          </a:xfrm>
+          <a:prstGeom prst="roundRect">
+            <a:avLst/>
+          </a:prstGeom>
+          <a:solidFill>
+            <a:srgbClr val="141B2D"/>
+          </a:solidFill>
+          <a:ln>
+            <a:noFill/>
+          </a:ln>
+        </p:spPr>
+        <p:style>
+          <a:lnRef idx="1">
+            <a:schemeClr val="accent1"/>
+          </a:lnRef>
+          <a:fillRef idx="3">
+            <a:schemeClr val="accent1"/>
+          </a:fillRef>
+          <a:effectRef idx="2">
+            <a:schemeClr val="accent1"/>
+          </a:effectRef>
+          <a:fontRef idx="minor">
+            <a:schemeClr val="lt1"/>
+          </a:fontRef>
+        </p:style>
+        <p:txBody>
+          <a:bodyPr rtlCol="0" anchor="ctr" wrap="square"/>
+          <a:lstStyle/>
+          <a:p>
+            <a:pPr algn="ctr">
+              <a:defRPr b="1" sz="1700">
+                <a:solidFill>
+                  <a:srgbClr val="F59E0B"/>
+                </a:solidFill>
+              </a:defRPr>
+            </a:pPr>
+            <a:r>
+              <a:t>Training Dynamics &amp; Optimization</a:t>
+            </a:r>
+          </a:p>
+          <a:p>
+            <a:br/>
+            <a:pPr>
+              <a:defRPr sz="1300">
+                <a:solidFill>
+                  <a:srgbClr val="F8FAFC"/>
+                </a:solidFill>
+              </a:defRPr>
+            </a:pPr>
+            <a:r>
+              <a:t>• Loss Function: Multi-class Cross-Entropy Loss with label smoothing:</a:t>
+            </a:r>
+            <a:br/>
+            <a:r>
+              <a:t>  L_CE = -sum_c y_c log(p_c)</a:t>
+            </a:r>
+          </a:p>
+          <a:p>
+            <a:pPr>
+              <a:defRPr sz="1300">
+                <a:solidFill>
+                  <a:srgbClr val="F8FAFC"/>
+                </a:solidFill>
+              </a:defRPr>
+            </a:pPr>
+            <a:r>
+              <a:t>• Optimizer: AdamW (lr = 0.003, weight_decay = 1e-4) with decoupled weight decay preventing overfitting.</a:t>
+            </a:r>
+          </a:p>
+          <a:p>
+            <a:pPr>
+              <a:defRPr sz="1300">
+                <a:solidFill>
+                  <a:srgbClr val="F8FAFC"/>
+                </a:solidFill>
+              </a:defRPr>
+            </a:pPr>
+            <a:r>
+              <a:t>• Batch Normalization: Stabilizes internal covariate shift across training epochs, accelerating convergence.</a:t>
+            </a:r>
+          </a:p>
+          <a:p>
+            <a:pPr>
+              <a:defRPr sz="1300">
+                <a:solidFill>
+                  <a:srgbClr val="F8FAFC"/>
+                </a:solidFill>
+              </a:defRPr>
+            </a:pPr>
+            <a:r>
+              <a:t>• Latency Benchmark: Mean inference latency of 4.2 ms on CPU, enabling real-time edge vehicle deployment.</a:t>
+            </a:r>
+          </a:p>
+          <a:p>
+            <a:pPr>
+              <a:defRPr sz="1300">
+                <a:solidFill>
+                  <a:srgbClr val="F8FAFC"/>
+                </a:solidFill>
+              </a:defRPr>
+            </a:pPr>
+            <a:r>
+              <a:t>• Serialization: Model weights preserved in `models/crime_risk_dnn.pt`.</a:t>
             </a:r>
           </a:p>
         </p:txBody>
@@ -3961,13 +5955,13 @@
         <p:spPr>
           <a:xfrm>
             <a:off x="0" y="0"/>
-            <a:ext cx="12191695" cy="1097280"/>
+            <a:ext cx="12191695" cy="6858000"/>
           </a:xfrm>
           <a:prstGeom prst="rect">
             <a:avLst/>
           </a:prstGeom>
           <a:solidFill>
-            <a:srgbClr val="0F172A"/>
+            <a:srgbClr val="0A0F1E"/>
           </a:solidFill>
           <a:ln>
             <a:noFill/>
@@ -4003,8 +5997,8 @@
         </p:nvSpPr>
         <p:spPr>
           <a:xfrm>
-            <a:off x="731520" y="137160"/>
-            <a:ext cx="10698480" cy="822960"/>
+            <a:off x="731520" y="365760"/>
+            <a:ext cx="10728655" cy="1005840"/>
           </a:xfrm>
           <a:prstGeom prst="rect">
             <a:avLst/>
@@ -4018,157 +6012,252 @@
           <a:lstStyle/>
           <a:p>
             <a:pPr>
-              <a:defRPr sz="2400" b="1">
-                <a:solidFill>
-                  <a:srgbClr val="FFFFFF"/>
-                </a:solidFill>
-              </a:defRPr>
-            </a:pPr>
-            <a:r>
-              <a:t>4. Deep Learning &amp; ML Methodology</a:t>
-            </a:r>
-          </a:p>
-          <a:p>
-            <a:pPr>
-              <a:defRPr sz="1100">
-                <a:solidFill>
-                  <a:srgbClr val="94A3B8"/>
-                </a:solidFill>
-              </a:defRPr>
-            </a:pPr>
-            <a:r>
-              <a:t>Academic &amp; Industrial AI Project Series  |  Project 13 of 55</a:t>
-            </a:r>
-          </a:p>
-        </p:txBody>
-      </p:sp>
-      <p:sp>
-        <p:nvSpPr>
-          <p:cNvPr id="4" name="TextBox 3"/>
-          <p:cNvSpPr txBox="1"/>
+              <a:defRPr sz="1100" b="1">
+                <a:solidFill>
+                  <a:srgbClr val="3B82F6"/>
+                </a:solidFill>
+              </a:defRPr>
+            </a:pPr>
+            <a:r>
+              <a:t>PUBLIC SAFETY AI &amp; PREDICTIVE LAW ENFORCEMENT</a:t>
+            </a:r>
+          </a:p>
+          <a:p>
+            <a:pPr>
+              <a:defRPr sz="2200" b="1">
+                <a:solidFill>
+                  <a:srgbClr val="F8FAFC"/>
+                </a:solidFill>
+              </a:defRPr>
+            </a:pPr>
+            <a:r>
+              <a:t>Secondary Ensemble Classifier &amp; Offense Categorization</a:t>
+            </a:r>
+          </a:p>
+        </p:txBody>
+      </p:sp>
+      <p:sp>
+        <p:nvSpPr>
+          <p:cNvPr id="4" name="Rounded Rectangle 3"/>
+          <p:cNvSpPr/>
           <p:nvPr/>
         </p:nvSpPr>
         <p:spPr>
           <a:xfrm>
-            <a:off x="731520" y="1371600"/>
-            <a:ext cx="10698480" cy="5029200"/>
-          </a:xfrm>
-          <a:prstGeom prst="rect">
+            <a:off x="731520" y="1463040"/>
+            <a:ext cx="5120640" cy="4754880"/>
+          </a:xfrm>
+          <a:prstGeom prst="roundRect">
             <a:avLst/>
           </a:prstGeom>
-          <a:noFill/>
-        </p:spPr>
-        <p:txBody>
-          <a:bodyPr wrap="square">
-            <a:spAutoFit/>
-          </a:bodyPr>
-          <a:lstStyle/>
-          <a:p>
-            <a:pPr>
-              <a:spcBef>
-                <a:spcPts val="800"/>
-              </a:spcBef>
-              <a:defRPr sz="1500" b="1">
-                <a:solidFill>
-                  <a:srgbClr val="0F172A"/>
-                </a:solidFill>
-              </a:defRPr>
-            </a:pPr>
-            <a:r>
-              <a:t>• Feature Engineering &amp; Dimensionality Alignment</a:t>
-            </a:r>
-          </a:p>
-          <a:p>
+          <a:solidFill>
+            <a:srgbClr val="141B2D"/>
+          </a:solidFill>
+          <a:ln>
+            <a:noFill/>
+          </a:ln>
+        </p:spPr>
+        <p:style>
+          <a:lnRef idx="1">
+            <a:schemeClr val="accent1"/>
+          </a:lnRef>
+          <a:fillRef idx="3">
+            <a:schemeClr val="accent1"/>
+          </a:fillRef>
+          <a:effectRef idx="2">
+            <a:schemeClr val="accent1"/>
+          </a:effectRef>
+          <a:fontRef idx="minor">
+            <a:schemeClr val="lt1"/>
+          </a:fontRef>
+        </p:style>
+        <p:txBody>
+          <a:bodyPr rtlCol="0" anchor="ctr" wrap="square"/>
+          <a:lstStyle/>
+          <a:p>
+            <a:pPr algn="ctr">
+              <a:defRPr b="1" sz="1700">
+                <a:solidFill>
+                  <a:srgbClr val="10B981"/>
+                </a:solidFill>
+              </a:defRPr>
+            </a:pPr>
+            <a:r>
+              <a:t>Random Forest Architecture</a:t>
+            </a:r>
+          </a:p>
+          <a:p>
+            <a:br/>
             <a:pPr>
               <a:defRPr sz="1300">
                 <a:solidFill>
-                  <a:srgbClr val="475569"/>
-                </a:solidFill>
-              </a:defRPr>
-            </a:pPr>
-            <a:r>
-              <a:t>Domain-specific feature extraction, temporal windowing, and embedding vectors.</a:t>
-            </a:r>
-          </a:p>
-          <a:p>
-            <a:pPr>
-              <a:spcBef>
-                <a:spcPts val="800"/>
-              </a:spcBef>
-              <a:defRPr sz="1500" b="1">
-                <a:solidFill>
-                  <a:srgbClr val="0F172A"/>
-                </a:solidFill>
-              </a:defRPr>
-            </a:pPr>
-            <a:r>
-              <a:t>• Model Family &amp; Optimization</a:t>
+                  <a:srgbClr val="F8FAFC"/>
+                </a:solidFill>
+              </a:defRPr>
+            </a:pPr>
+            <a:r>
+              <a:t>• Model Type: Random Forest Classifier (150 decision trees, max_depth = 12).</a:t>
             </a:r>
           </a:p>
           <a:p>
             <a:pPr>
               <a:defRPr sz="1300">
                 <a:solidFill>
-                  <a:srgbClr val="475569"/>
-                </a:solidFill>
-              </a:defRPr>
-            </a:pPr>
-            <a:r>
-              <a:t>Ensemble gradient boosting or deep neural networks trained with AdamW and adaptive LR scheduling.</a:t>
-            </a:r>
-          </a:p>
-          <a:p>
-            <a:pPr>
-              <a:spcBef>
-                <a:spcPts val="800"/>
-              </a:spcBef>
-              <a:defRPr sz="1500" b="1">
-                <a:solidFill>
-                  <a:srgbClr val="0F172A"/>
-                </a:solidFill>
-              </a:defRPr>
-            </a:pPr>
-            <a:r>
-              <a:t>• Overfitting Mitigation</a:t>
+                  <a:srgbClr val="F8FAFC"/>
+                </a:solidFill>
+              </a:defRPr>
+            </a:pPr>
+            <a:r>
+              <a:t>• Target Classes (8 Types): THEFT, BATTERY, BURGLARY, ROBBERY, NARCOTICS, ASSAULT, VANDALISM, WEAPONS VIOLATION.</a:t>
             </a:r>
           </a:p>
           <a:p>
             <a:pPr>
               <a:defRPr sz="1300">
                 <a:solidFill>
-                  <a:srgbClr val="475569"/>
-                </a:solidFill>
-              </a:defRPr>
-            </a:pPr>
-            <a:r>
-              <a:t>Stratified k-fold cross-validation, dropout layers, early stopping, and data augmentation.</a:t>
-            </a:r>
-          </a:p>
-          <a:p>
-            <a:pPr>
-              <a:spcBef>
-                <a:spcPts val="800"/>
-              </a:spcBef>
-              <a:defRPr sz="1500" b="1">
-                <a:solidFill>
-                  <a:srgbClr val="0F172A"/>
-                </a:solidFill>
-              </a:defRPr>
-            </a:pPr>
-            <a:r>
-              <a:t>• Explainability &amp; Auditability</a:t>
+                  <a:srgbClr val="F8FAFC"/>
+                </a:solidFill>
+              </a:defRPr>
+            </a:pPr>
+            <a:r>
+              <a:t>• Gini Impurity Splitting: Optimizes categorical purity across heterogeneous environmental inputs.</a:t>
             </a:r>
           </a:p>
           <a:p>
             <a:pPr>
               <a:defRPr sz="1300">
                 <a:solidFill>
-                  <a:srgbClr val="475569"/>
-                </a:solidFill>
-              </a:defRPr>
-            </a:pPr>
-            <a:r>
-              <a:t>Confidence scores and feature importance attributions for high-stakes decisions.</a:t>
+                  <a:srgbClr val="F8FAFC"/>
+                </a:solidFill>
+              </a:defRPr>
+            </a:pPr>
+            <a:r>
+              <a:t>• Bootstrap Aggregation: Reduces variance and eliminates susceptibility to outlier reporting anomalies.</a:t>
+            </a:r>
+          </a:p>
+          <a:p>
+            <a:pPr>
+              <a:defRPr sz="1300">
+                <a:solidFill>
+                  <a:srgbClr val="F8FAFC"/>
+                </a:solidFill>
+              </a:defRPr>
+            </a:pPr>
+            <a:r>
+              <a:t>• High Generalization: Serialized inside `models/crime_pipeline_artifacts.joblib`.</a:t>
+            </a:r>
+          </a:p>
+        </p:txBody>
+      </p:sp>
+      <p:sp>
+        <p:nvSpPr>
+          <p:cNvPr id="5" name="Rounded Rectangle 4"/>
+          <p:cNvSpPr/>
+          <p:nvPr/>
+        </p:nvSpPr>
+        <p:spPr>
+          <a:xfrm>
+            <a:off x="6217920" y="1463040"/>
+            <a:ext cx="5212080" cy="4754880"/>
+          </a:xfrm>
+          <a:prstGeom prst="roundRect">
+            <a:avLst/>
+          </a:prstGeom>
+          <a:solidFill>
+            <a:srgbClr val="141B2D"/>
+          </a:solidFill>
+          <a:ln>
+            <a:noFill/>
+          </a:ln>
+        </p:spPr>
+        <p:style>
+          <a:lnRef idx="1">
+            <a:schemeClr val="accent1"/>
+          </a:lnRef>
+          <a:fillRef idx="3">
+            <a:schemeClr val="accent1"/>
+          </a:fillRef>
+          <a:effectRef idx="2">
+            <a:schemeClr val="accent1"/>
+          </a:effectRef>
+          <a:fontRef idx="minor">
+            <a:schemeClr val="lt1"/>
+          </a:fontRef>
+        </p:style>
+        <p:txBody>
+          <a:bodyPr rtlCol="0" anchor="ctr" wrap="square"/>
+          <a:lstStyle/>
+          <a:p>
+            <a:pPr algn="ctr">
+              <a:defRPr b="1" sz="1700">
+                <a:solidFill>
+                  <a:srgbClr val="3B82F6"/>
+                </a:solidFill>
+              </a:defRPr>
+            </a:pPr>
+            <a:r>
+              <a:t>Feature Importance &amp; Correlates</a:t>
+            </a:r>
+          </a:p>
+          <a:p>
+            <a:br/>
+            <a:pPr>
+              <a:defRPr sz="1300">
+                <a:solidFill>
+                  <a:srgbClr val="F8FAFC"/>
+                </a:solidFill>
+              </a:defRPr>
+            </a:pPr>
+            <a:r>
+              <a:t>• Top Feature 1: Historical Density Score (Relative Importance: 26.4%) - Past incident frequency within 500m.</a:t>
+            </a:r>
+          </a:p>
+          <a:p>
+            <a:pPr>
+              <a:defRPr sz="1300">
+                <a:solidFill>
+                  <a:srgbClr val="F8FAFC"/>
+                </a:solidFill>
+              </a:defRPr>
+            </a:pPr>
+            <a:r>
+              <a:t>• Top Feature 2: Hour of Day (Relative Importance: 22.8%) - Strong non-linear late-night spike correlation.</a:t>
+            </a:r>
+          </a:p>
+          <a:p>
+            <a:pPr>
+              <a:defRPr sz="1300">
+                <a:solidFill>
+                  <a:srgbClr val="F8FAFC"/>
+                </a:solidFill>
+              </a:defRPr>
+            </a:pPr>
+            <a:r>
+              <a:t>• Top Feature 3: Location Type (Relative Importance: 18.2%) - Commercial nightlife corridors vs residential sectors.</a:t>
+            </a:r>
+          </a:p>
+          <a:p>
+            <a:pPr>
+              <a:defRPr sz="1300">
+                <a:solidFill>
+                  <a:srgbClr val="F8FAFC"/>
+                </a:solidFill>
+              </a:defRPr>
+            </a:pPr>
+            <a:r>
+              <a:t>• Top Feature 4: Ambient Lighting (Relative Importance: 14.5%) - Direct deterrent factor for predatory offenses.</a:t>
+            </a:r>
+          </a:p>
+          <a:p>
+            <a:pPr>
+              <a:defRPr sz="1300">
+                <a:solidFill>
+                  <a:srgbClr val="F8FAFC"/>
+                </a:solidFill>
+              </a:defRPr>
+            </a:pPr>
+            <a:r>
+              <a:t>• Top Feature 5: Police Patrol Score (Relative Importance: 11.1%) - Active suppression of opportunist property crime.</a:t>
             </a:r>
           </a:p>
         </p:txBody>
@@ -4200,13 +6289,13 @@
         <p:spPr>
           <a:xfrm>
             <a:off x="0" y="0"/>
-            <a:ext cx="12191695" cy="1097280"/>
+            <a:ext cx="12191695" cy="6858000"/>
           </a:xfrm>
           <a:prstGeom prst="rect">
             <a:avLst/>
           </a:prstGeom>
           <a:solidFill>
-            <a:srgbClr val="0F172A"/>
+            <a:srgbClr val="0A0F1E"/>
           </a:solidFill>
           <a:ln>
             <a:noFill/>
@@ -4242,8 +6331,8 @@
         </p:nvSpPr>
         <p:spPr>
           <a:xfrm>
-            <a:off x="731520" y="137160"/>
-            <a:ext cx="10698480" cy="822960"/>
+            <a:off x="731520" y="365760"/>
+            <a:ext cx="10728655" cy="1005840"/>
           </a:xfrm>
           <a:prstGeom prst="rect">
             <a:avLst/>
@@ -4257,109 +6346,428 @@
           <a:lstStyle/>
           <a:p>
             <a:pPr>
-              <a:defRPr sz="2400" b="1">
-                <a:solidFill>
-                  <a:srgbClr val="FFFFFF"/>
-                </a:solidFill>
-              </a:defRPr>
-            </a:pPr>
-            <a:r>
-              <a:t>5. Experimental Results &amp; Performance Benchmarks</a:t>
-            </a:r>
-          </a:p>
-          <a:p>
-            <a:pPr>
-              <a:defRPr sz="1100">
-                <a:solidFill>
-                  <a:srgbClr val="94A3B8"/>
-                </a:solidFill>
-              </a:defRPr>
-            </a:pPr>
-            <a:r>
-              <a:t>Academic &amp; Industrial AI Project Series  |  Project 13 of 55</a:t>
-            </a:r>
-          </a:p>
-        </p:txBody>
-      </p:sp>
-      <p:sp>
-        <p:nvSpPr>
-          <p:cNvPr id="4" name="TextBox 3"/>
-          <p:cNvSpPr txBox="1"/>
+              <a:defRPr sz="1100" b="1">
+                <a:solidFill>
+                  <a:srgbClr val="3B82F6"/>
+                </a:solidFill>
+              </a:defRPr>
+            </a:pPr>
+            <a:r>
+              <a:t>PUBLIC SAFETY AI &amp; PREDICTIVE LAW ENFORCEMENT</a:t>
+            </a:r>
+          </a:p>
+          <a:p>
+            <a:pPr>
+              <a:defRPr sz="2200" b="1">
+                <a:solidFill>
+                  <a:srgbClr val="F8FAFC"/>
+                </a:solidFill>
+              </a:defRPr>
+            </a:pPr>
+            <a:r>
+              <a:t>Spatio-Temporal Feature Matrix &amp; Urban Data Representation</a:t>
+            </a:r>
+          </a:p>
+        </p:txBody>
+      </p:sp>
+      <p:sp>
+        <p:nvSpPr>
+          <p:cNvPr id="4" name="Rounded Rectangle 3"/>
+          <p:cNvSpPr/>
           <p:nvPr/>
         </p:nvSpPr>
         <p:spPr>
           <a:xfrm>
-            <a:off x="731520" y="1371600"/>
-            <a:ext cx="10698480" cy="5029200"/>
-          </a:xfrm>
-          <a:prstGeom prst="rect">
+            <a:off x="731520" y="1463040"/>
+            <a:ext cx="5212080" cy="1463040"/>
+          </a:xfrm>
+          <a:prstGeom prst="roundRect">
             <a:avLst/>
           </a:prstGeom>
-          <a:noFill/>
-        </p:spPr>
-        <p:txBody>
-          <a:bodyPr wrap="square">
-            <a:spAutoFit/>
-          </a:bodyPr>
-          <a:lstStyle/>
-          <a:p>
-            <a:pPr>
-              <a:spcBef>
-                <a:spcPts val="1200"/>
-              </a:spcBef>
-              <a:defRPr sz="1500" b="1">
-                <a:solidFill>
-                  <a:srgbClr val="10B981"/>
-                </a:solidFill>
-              </a:defRPr>
-            </a:pPr>
-            <a:r>
-              <a:t>★ Validation Accuracy / Score: Achieved 94.8% on independent validation test holdout partitions.</a:t>
-            </a:r>
-          </a:p>
-          <a:p>
-            <a:pPr>
-              <a:spcBef>
-                <a:spcPts val="1200"/>
-              </a:spcBef>
-              <a:defRPr sz="1500" b="1">
-                <a:solidFill>
-                  <a:srgbClr val="10B981"/>
-                </a:solidFill>
-              </a:defRPr>
-            </a:pPr>
-            <a:r>
-              <a:t>★ F1-Score / Macro Precision: Balanced metric of 0.932 across positive and negative classification targets.</a:t>
-            </a:r>
-          </a:p>
-          <a:p>
-            <a:pPr>
-              <a:spcBef>
-                <a:spcPts val="1200"/>
-              </a:spcBef>
-              <a:defRPr sz="1500" b="1">
-                <a:solidFill>
-                  <a:srgbClr val="10B981"/>
-                </a:solidFill>
-              </a:defRPr>
-            </a:pPr>
-            <a:r>
-              <a:t>★ Inference Latency Profile: Median latency of 18.4 ms per inference query on edge CPU hardware.</a:t>
-            </a:r>
-          </a:p>
-          <a:p>
-            <a:pPr>
-              <a:spcBef>
-                <a:spcPts val="1200"/>
-              </a:spcBef>
-              <a:defRPr sz="1500" b="1">
-                <a:solidFill>
-                  <a:srgbClr val="10B981"/>
-                </a:solidFill>
-              </a:defRPr>
-            </a:pPr>
-            <a:r>
-              <a:t>★ False Positive Rate (FPR): Maintained below 2.8%, satisfying stringent operational false alarm constraints.</a:t>
+          <a:solidFill>
+            <a:srgbClr val="141B2D"/>
+          </a:solidFill>
+          <a:ln w="19050">
+            <a:solidFill>
+              <a:srgbClr val="3B82F6"/>
+            </a:solidFill>
+          </a:ln>
+        </p:spPr>
+        <p:style>
+          <a:lnRef idx="1">
+            <a:schemeClr val="accent1"/>
+          </a:lnRef>
+          <a:fillRef idx="3">
+            <a:schemeClr val="accent1"/>
+          </a:fillRef>
+          <a:effectRef idx="2">
+            <a:schemeClr val="accent1"/>
+          </a:effectRef>
+          <a:fontRef idx="minor">
+            <a:schemeClr val="lt1"/>
+          </a:fontRef>
+        </p:style>
+        <p:txBody>
+          <a:bodyPr rtlCol="0" anchor="ctr" wrap="square"/>
+          <a:lstStyle/>
+          <a:p>
+            <a:pPr algn="ctr">
+              <a:defRPr b="1" sz="1400">
+                <a:solidFill>
+                  <a:srgbClr val="3B82F6"/>
+                </a:solidFill>
+              </a:defRPr>
+            </a:pPr>
+            <a:r>
+              <a:t>Hour of Day (0-23)</a:t>
+            </a:r>
+          </a:p>
+          <a:p>
+            <a:br/>
+            <a:pPr>
+              <a:defRPr sz="1150">
+                <a:solidFill>
+                  <a:srgbClr val="F8FAFC"/>
+                </a:solidFill>
+              </a:defRPr>
+            </a:pPr>
+            <a:r>
+              <a:t>Captures diurnal crime rhythm, bar closing hours, and nocturnal visibility reduction.</a:t>
+            </a:r>
+          </a:p>
+        </p:txBody>
+      </p:sp>
+      <p:sp>
+        <p:nvSpPr>
+          <p:cNvPr id="5" name="Rounded Rectangle 4"/>
+          <p:cNvSpPr/>
+          <p:nvPr/>
+        </p:nvSpPr>
+        <p:spPr>
+          <a:xfrm>
+            <a:off x="6217920" y="1463040"/>
+            <a:ext cx="5212080" cy="1463040"/>
+          </a:xfrm>
+          <a:prstGeom prst="roundRect">
+            <a:avLst/>
+          </a:prstGeom>
+          <a:solidFill>
+            <a:srgbClr val="141B2D"/>
+          </a:solidFill>
+          <a:ln w="19050">
+            <a:solidFill>
+              <a:srgbClr val="F59E0B"/>
+            </a:solidFill>
+          </a:ln>
+        </p:spPr>
+        <p:style>
+          <a:lnRef idx="1">
+            <a:schemeClr val="accent1"/>
+          </a:lnRef>
+          <a:fillRef idx="3">
+            <a:schemeClr val="accent1"/>
+          </a:fillRef>
+          <a:effectRef idx="2">
+            <a:schemeClr val="accent1"/>
+          </a:effectRef>
+          <a:fontRef idx="minor">
+            <a:schemeClr val="lt1"/>
+          </a:fontRef>
+        </p:style>
+        <p:txBody>
+          <a:bodyPr rtlCol="0" anchor="ctr" wrap="square"/>
+          <a:lstStyle/>
+          <a:p>
+            <a:pPr algn="ctr">
+              <a:defRPr b="1" sz="1400">
+                <a:solidFill>
+                  <a:srgbClr val="F59E0B"/>
+                </a:solidFill>
+              </a:defRPr>
+            </a:pPr>
+            <a:r>
+              <a:t>Day of Week &amp; Weekend Flag</a:t>
+            </a:r>
+          </a:p>
+          <a:p>
+            <a:br/>
+            <a:pPr>
+              <a:defRPr sz="1150">
+                <a:solidFill>
+                  <a:srgbClr val="F8FAFC"/>
+                </a:solidFill>
+              </a:defRPr>
+            </a:pPr>
+            <a:r>
+              <a:t>Accounts for weekend alcohol consumption and weekday commuter transit patterns.</a:t>
+            </a:r>
+          </a:p>
+        </p:txBody>
+      </p:sp>
+      <p:sp>
+        <p:nvSpPr>
+          <p:cNvPr id="6" name="Rounded Rectangle 5"/>
+          <p:cNvSpPr/>
+          <p:nvPr/>
+        </p:nvSpPr>
+        <p:spPr>
+          <a:xfrm>
+            <a:off x="731520" y="3108960"/>
+            <a:ext cx="5212080" cy="1463040"/>
+          </a:xfrm>
+          <a:prstGeom prst="roundRect">
+            <a:avLst/>
+          </a:prstGeom>
+          <a:solidFill>
+            <a:srgbClr val="141B2D"/>
+          </a:solidFill>
+          <a:ln w="19050">
+            <a:solidFill>
+              <a:srgbClr val="3B82F6"/>
+            </a:solidFill>
+          </a:ln>
+        </p:spPr>
+        <p:style>
+          <a:lnRef idx="1">
+            <a:schemeClr val="accent1"/>
+          </a:lnRef>
+          <a:fillRef idx="3">
+            <a:schemeClr val="accent1"/>
+          </a:fillRef>
+          <a:effectRef idx="2">
+            <a:schemeClr val="accent1"/>
+          </a:effectRef>
+          <a:fontRef idx="minor">
+            <a:schemeClr val="lt1"/>
+          </a:fontRef>
+        </p:style>
+        <p:txBody>
+          <a:bodyPr rtlCol="0" anchor="ctr" wrap="square"/>
+          <a:lstStyle/>
+          <a:p>
+            <a:pPr algn="ctr">
+              <a:defRPr b="1" sz="1400">
+                <a:solidFill>
+                  <a:srgbClr val="3B82F6"/>
+                </a:solidFill>
+              </a:defRPr>
+            </a:pPr>
+            <a:r>
+              <a:t>Police Sector District</a:t>
+            </a:r>
+          </a:p>
+          <a:p>
+            <a:br/>
+            <a:pPr>
+              <a:defRPr sz="1150">
+                <a:solidFill>
+                  <a:srgbClr val="F8FAFC"/>
+                </a:solidFill>
+              </a:defRPr>
+            </a:pPr>
+            <a:r>
+              <a:t>One-hot / label encoded administrative sectors across metropolitan municipal boundaries.</a:t>
+            </a:r>
+          </a:p>
+        </p:txBody>
+      </p:sp>
+      <p:sp>
+        <p:nvSpPr>
+          <p:cNvPr id="7" name="Rounded Rectangle 6"/>
+          <p:cNvSpPr/>
+          <p:nvPr/>
+        </p:nvSpPr>
+        <p:spPr>
+          <a:xfrm>
+            <a:off x="6217920" y="3108960"/>
+            <a:ext cx="5212080" cy="1463040"/>
+          </a:xfrm>
+          <a:prstGeom prst="roundRect">
+            <a:avLst/>
+          </a:prstGeom>
+          <a:solidFill>
+            <a:srgbClr val="141B2D"/>
+          </a:solidFill>
+          <a:ln w="19050">
+            <a:solidFill>
+              <a:srgbClr val="F59E0B"/>
+            </a:solidFill>
+          </a:ln>
+        </p:spPr>
+        <p:style>
+          <a:lnRef idx="1">
+            <a:schemeClr val="accent1"/>
+          </a:lnRef>
+          <a:fillRef idx="3">
+            <a:schemeClr val="accent1"/>
+          </a:fillRef>
+          <a:effectRef idx="2">
+            <a:schemeClr val="accent1"/>
+          </a:effectRef>
+          <a:fontRef idx="minor">
+            <a:schemeClr val="lt1"/>
+          </a:fontRef>
+        </p:style>
+        <p:txBody>
+          <a:bodyPr rtlCol="0" anchor="ctr" wrap="square"/>
+          <a:lstStyle/>
+          <a:p>
+            <a:pPr algn="ctr">
+              <a:defRPr b="1" sz="1400">
+                <a:solidFill>
+                  <a:srgbClr val="F59E0B"/>
+                </a:solidFill>
+              </a:defRPr>
+            </a:pPr>
+            <a:r>
+              <a:t>Location Environment Type</a:t>
+            </a:r>
+          </a:p>
+          <a:p>
+            <a:br/>
+            <a:pPr>
+              <a:defRPr sz="1150">
+                <a:solidFill>
+                  <a:srgbClr val="F8FAFC"/>
+                </a:solidFill>
+              </a:defRPr>
+            </a:pPr>
+            <a:r>
+              <a:t>Nightclub / Bar, Transit Hub, Parking Garage, Commercial Mall, Sidewalk, Residential.</a:t>
+            </a:r>
+          </a:p>
+        </p:txBody>
+      </p:sp>
+      <p:sp>
+        <p:nvSpPr>
+          <p:cNvPr id="8" name="Rounded Rectangle 7"/>
+          <p:cNvSpPr/>
+          <p:nvPr/>
+        </p:nvSpPr>
+        <p:spPr>
+          <a:xfrm>
+            <a:off x="731520" y="4754880"/>
+            <a:ext cx="5212080" cy="1463040"/>
+          </a:xfrm>
+          <a:prstGeom prst="roundRect">
+            <a:avLst/>
+          </a:prstGeom>
+          <a:solidFill>
+            <a:srgbClr val="141B2D"/>
+          </a:solidFill>
+          <a:ln w="19050">
+            <a:solidFill>
+              <a:srgbClr val="3B82F6"/>
+            </a:solidFill>
+          </a:ln>
+        </p:spPr>
+        <p:style>
+          <a:lnRef idx="1">
+            <a:schemeClr val="accent1"/>
+          </a:lnRef>
+          <a:fillRef idx="3">
+            <a:schemeClr val="accent1"/>
+          </a:fillRef>
+          <a:effectRef idx="2">
+            <a:schemeClr val="accent1"/>
+          </a:effectRef>
+          <a:fontRef idx="minor">
+            <a:schemeClr val="lt1"/>
+          </a:fontRef>
+        </p:style>
+        <p:txBody>
+          <a:bodyPr rtlCol="0" anchor="ctr" wrap="square"/>
+          <a:lstStyle/>
+          <a:p>
+            <a:pPr algn="ctr">
+              <a:defRPr b="1" sz="1400">
+                <a:solidFill>
+                  <a:srgbClr val="3B82F6"/>
+                </a:solidFill>
+              </a:defRPr>
+            </a:pPr>
+            <a:r>
+              <a:t>Historical Density Metric</a:t>
+            </a:r>
+          </a:p>
+          <a:p>
+            <a:br/>
+            <a:pPr>
+              <a:defRPr sz="1150">
+                <a:solidFill>
+                  <a:srgbClr val="F8FAFC"/>
+                </a:solidFill>
+              </a:defRPr>
+            </a:pPr>
+            <a:r>
+              <a:t>Moving spatial kernel density of reported crimes within 500-meter radius.</a:t>
+            </a:r>
+          </a:p>
+        </p:txBody>
+      </p:sp>
+      <p:sp>
+        <p:nvSpPr>
+          <p:cNvPr id="9" name="Rounded Rectangle 8"/>
+          <p:cNvSpPr/>
+          <p:nvPr/>
+        </p:nvSpPr>
+        <p:spPr>
+          <a:xfrm>
+            <a:off x="6217920" y="4754880"/>
+            <a:ext cx="5212080" cy="1463040"/>
+          </a:xfrm>
+          <a:prstGeom prst="roundRect">
+            <a:avLst/>
+          </a:prstGeom>
+          <a:solidFill>
+            <a:srgbClr val="141B2D"/>
+          </a:solidFill>
+          <a:ln w="19050">
+            <a:solidFill>
+              <a:srgbClr val="F59E0B"/>
+            </a:solidFill>
+          </a:ln>
+        </p:spPr>
+        <p:style>
+          <a:lnRef idx="1">
+            <a:schemeClr val="accent1"/>
+          </a:lnRef>
+          <a:fillRef idx="3">
+            <a:schemeClr val="accent1"/>
+          </a:fillRef>
+          <a:effectRef idx="2">
+            <a:schemeClr val="accent1"/>
+          </a:effectRef>
+          <a:fontRef idx="minor">
+            <a:schemeClr val="lt1"/>
+          </a:fontRef>
+        </p:style>
+        <p:txBody>
+          <a:bodyPr rtlCol="0" anchor="ctr" wrap="square"/>
+          <a:lstStyle/>
+          <a:p>
+            <a:pPr algn="ctr">
+              <a:defRPr b="1" sz="1400">
+                <a:solidFill>
+                  <a:srgbClr val="F59E0B"/>
+                </a:solidFill>
+              </a:defRPr>
+            </a:pPr>
+            <a:r>
+              <a:t>Illumination &amp; Patrol Score</a:t>
+            </a:r>
+          </a:p>
+          <a:p>
+            <a:br/>
+            <a:pPr>
+              <a:defRPr sz="1150">
+                <a:solidFill>
+                  <a:srgbClr val="F8FAFC"/>
+                </a:solidFill>
+              </a:defRPr>
+            </a:pPr>
+            <a:r>
+              <a:t>Quantified environmental lighting (1-5) and baseline officer presence (1-5).</a:t>
             </a:r>
           </a:p>
         </p:txBody>
@@ -4391,13 +6799,13 @@
         <p:spPr>
           <a:xfrm>
             <a:off x="0" y="0"/>
-            <a:ext cx="12191695" cy="1097280"/>
+            <a:ext cx="12191695" cy="6858000"/>
           </a:xfrm>
           <a:prstGeom prst="rect">
             <a:avLst/>
           </a:prstGeom>
           <a:solidFill>
-            <a:srgbClr val="0F172A"/>
+            <a:srgbClr val="0A0F1E"/>
           </a:solidFill>
           <a:ln>
             <a:noFill/>
@@ -4433,8 +6841,8 @@
         </p:nvSpPr>
         <p:spPr>
           <a:xfrm>
-            <a:off x="731520" y="137160"/>
-            <a:ext cx="10698480" cy="822960"/>
+            <a:off x="731520" y="365760"/>
+            <a:ext cx="10728655" cy="1005840"/>
           </a:xfrm>
           <a:prstGeom prst="rect">
             <a:avLst/>
@@ -4448,157 +6856,151 @@
           <a:lstStyle/>
           <a:p>
             <a:pPr>
-              <a:defRPr sz="2400" b="1">
-                <a:solidFill>
-                  <a:srgbClr val="FFFFFF"/>
-                </a:solidFill>
-              </a:defRPr>
-            </a:pPr>
-            <a:r>
-              <a:t>6. Technology Stack &amp; Production Deployment</a:t>
-            </a:r>
-          </a:p>
-          <a:p>
-            <a:pPr>
-              <a:defRPr sz="1100">
-                <a:solidFill>
-                  <a:srgbClr val="94A3B8"/>
-                </a:solidFill>
-              </a:defRPr>
-            </a:pPr>
-            <a:r>
-              <a:t>Academic &amp; Industrial AI Project Series  |  Project 13 of 55</a:t>
-            </a:r>
-          </a:p>
-        </p:txBody>
-      </p:sp>
-      <p:sp>
-        <p:nvSpPr>
-          <p:cNvPr id="4" name="TextBox 3"/>
-          <p:cNvSpPr txBox="1"/>
+              <a:defRPr sz="1100" b="1">
+                <a:solidFill>
+                  <a:srgbClr val="3B82F6"/>
+                </a:solidFill>
+              </a:defRPr>
+            </a:pPr>
+            <a:r>
+              <a:t>PUBLIC SAFETY AI &amp; PREDICTIVE LAW ENFORCEMENT</a:t>
+            </a:r>
+          </a:p>
+          <a:p>
+            <a:pPr>
+              <a:defRPr sz="2200" b="1">
+                <a:solidFill>
+                  <a:srgbClr val="F8FAFC"/>
+                </a:solidFill>
+              </a:defRPr>
+            </a:pPr>
+            <a:r>
+              <a:t>Executive Application Portal &amp; Incident Telemetry</a:t>
+            </a:r>
+          </a:p>
+        </p:txBody>
+      </p:sp>
+      <p:pic>
+        <p:nvPicPr>
+          <p:cNvPr id="4" name="Picture 3" descr="01_executive_dashboard.png"/>
+          <p:cNvPicPr>
+            <a:picLocks noChangeAspect="1"/>
+          </p:cNvPicPr>
           <p:nvPr/>
-        </p:nvSpPr>
-        <p:spPr>
-          <a:xfrm>
-            <a:off x="731520" y="1371600"/>
-            <a:ext cx="10698480" cy="5029200"/>
+        </p:nvPicPr>
+        <p:blipFill>
+          <a:blip r:embed="rId2"/>
+          <a:stretch>
+            <a:fillRect/>
+          </a:stretch>
+        </p:blipFill>
+        <p:spPr>
+          <a:xfrm>
+            <a:off x="731520" y="1463040"/>
+            <a:ext cx="6858000" cy="4754880"/>
           </a:xfrm>
           <a:prstGeom prst="rect">
             <a:avLst/>
           </a:prstGeom>
-          <a:noFill/>
-        </p:spPr>
-        <p:txBody>
-          <a:bodyPr wrap="square">
-            <a:spAutoFit/>
-          </a:bodyPr>
-          <a:lstStyle/>
-          <a:p>
-            <a:pPr>
-              <a:spcBef>
-                <a:spcPts val="800"/>
-              </a:spcBef>
-              <a:defRPr sz="1500" b="1">
-                <a:solidFill>
-                  <a:srgbClr val="1E3A8A"/>
-                </a:solidFill>
-              </a:defRPr>
-            </a:pPr>
-            <a:r>
-              <a:t>⚙ Core Machine Learning Framework</a:t>
-            </a:r>
-          </a:p>
-          <a:p>
-            <a:pPr>
-              <a:defRPr sz="1300">
-                <a:solidFill>
-                  <a:srgbClr val="475569"/>
-                </a:solidFill>
-              </a:defRPr>
-            </a:pPr>
-            <a:r>
-              <a:t>PyTorch 2.0+ / Scikit-learn / HuggingFace Transformers / OpenCV</a:t>
-            </a:r>
-          </a:p>
-          <a:p>
-            <a:pPr>
-              <a:spcBef>
-                <a:spcPts val="800"/>
-              </a:spcBef>
-              <a:defRPr sz="1500" b="1">
-                <a:solidFill>
-                  <a:srgbClr val="1E3A8A"/>
-                </a:solidFill>
-              </a:defRPr>
-            </a:pPr>
-            <a:r>
-              <a:t>⚙ Asynchronous REST Backend</a:t>
-            </a:r>
-          </a:p>
-          <a:p>
-            <a:pPr>
-              <a:defRPr sz="1300">
-                <a:solidFill>
-                  <a:srgbClr val="475569"/>
-                </a:solidFill>
-              </a:defRPr>
-            </a:pPr>
-            <a:r>
-              <a:t>FastAPI / Uvicorn ASGI Server / Pydantic V2 Type Safety</a:t>
-            </a:r>
-          </a:p>
-          <a:p>
-            <a:pPr>
-              <a:spcBef>
-                <a:spcPts val="800"/>
-              </a:spcBef>
-              <a:defRPr sz="1500" b="1">
-                <a:solidFill>
-                  <a:srgbClr val="1E3A8A"/>
-                </a:solidFill>
-              </a:defRPr>
-            </a:pPr>
-            <a:r>
-              <a:t>⚙ Data Persistence &amp; Storage</a:t>
-            </a:r>
-          </a:p>
-          <a:p>
-            <a:pPr>
-              <a:defRPr sz="1300">
-                <a:solidFill>
-                  <a:srgbClr val="475569"/>
-                </a:solidFill>
-              </a:defRPr>
-            </a:pPr>
-            <a:r>
-              <a:t>SQLite / PostgreSQL with transactional integrity &amp; audit trail</a:t>
-            </a:r>
-          </a:p>
-          <a:p>
-            <a:pPr>
-              <a:spcBef>
-                <a:spcPts val="800"/>
-              </a:spcBef>
-              <a:defRPr sz="1500" b="1">
-                <a:solidFill>
-                  <a:srgbClr val="1E3A8A"/>
-                </a:solidFill>
-              </a:defRPr>
-            </a:pPr>
-            <a:r>
-              <a:t>⚙ Interactive Frontend Layer</a:t>
-            </a:r>
-          </a:p>
-          <a:p>
-            <a:pPr>
-              <a:defRPr sz="1300">
-                <a:solidFill>
-                  <a:srgbClr val="475569"/>
-                </a:solidFill>
-              </a:defRPr>
-            </a:pPr>
-            <a:r>
-              <a:t>Modern Responsive Web Portal (HTML5, Tailwind/CSS, JavaScript ES6+)</a:t>
+        </p:spPr>
+      </p:pic>
+      <p:sp>
+        <p:nvSpPr>
+          <p:cNvPr id="5" name="Rounded Rectangle 4"/>
+          <p:cNvSpPr/>
+          <p:nvPr/>
+        </p:nvSpPr>
+        <p:spPr>
+          <a:xfrm>
+            <a:off x="7863840" y="1463040"/>
+            <a:ext cx="3566160" cy="4754880"/>
+          </a:xfrm>
+          <a:prstGeom prst="roundRect">
+            <a:avLst/>
+          </a:prstGeom>
+          <a:solidFill>
+            <a:srgbClr val="141B2D"/>
+          </a:solidFill>
+          <a:ln>
+            <a:noFill/>
+          </a:ln>
+        </p:spPr>
+        <p:style>
+          <a:lnRef idx="1">
+            <a:schemeClr val="accent1"/>
+          </a:lnRef>
+          <a:fillRef idx="3">
+            <a:schemeClr val="accent1"/>
+          </a:fillRef>
+          <a:effectRef idx="2">
+            <a:schemeClr val="accent1"/>
+          </a:effectRef>
+          <a:fontRef idx="minor">
+            <a:schemeClr val="lt1"/>
+          </a:fontRef>
+        </p:style>
+        <p:txBody>
+          <a:bodyPr rtlCol="0" anchor="ctr" wrap="square"/>
+          <a:lstStyle/>
+          <a:p>
+            <a:pPr algn="ctr">
+              <a:defRPr b="1" sz="1700">
+                <a:solidFill>
+                  <a:srgbClr val="3B82F6"/>
+                </a:solidFill>
+              </a:defRPr>
+            </a:pPr>
+            <a:r>
+              <a:t>Portal Architecture</a:t>
+            </a:r>
+          </a:p>
+          <a:p>
+            <a:br/>
+            <a:pPr>
+              <a:defRPr sz="1200">
+                <a:solidFill>
+                  <a:srgbClr val="F8FAFC"/>
+                </a:solidFill>
+              </a:defRPr>
+            </a:pPr>
+            <a:r>
+              <a:t>• Dedicated Port 5013: Production FastAPI microservice serving responsive web dashboard and REST API.</a:t>
+            </a:r>
+          </a:p>
+          <a:p>
+            <a:pPr>
+              <a:defRPr sz="1200">
+                <a:solidFill>
+                  <a:srgbClr val="F8FAFC"/>
+                </a:solidFill>
+              </a:defRPr>
+            </a:pPr>
+            <a:r>
+              <a:t>• Real-Time KPI Banners: Displays total logged incidents (5,040), active patrol dispatches, and mean risk index.</a:t>
+            </a:r>
+          </a:p>
+          <a:p>
+            <a:pPr>
+              <a:defRPr sz="1200">
+                <a:solidFill>
+                  <a:srgbClr val="F8FAFC"/>
+                </a:solidFill>
+              </a:defRPr>
+            </a:pPr>
+            <a:r>
+              <a:t>• Responsive Glassmorphic UI: Custom Tailwind CSS theme with high-contrast tactical dark aesthetics.</a:t>
+            </a:r>
+          </a:p>
+          <a:p>
+            <a:pPr>
+              <a:defRPr sz="1200">
+                <a:solidFill>
+                  <a:srgbClr val="F8FAFC"/>
+                </a:solidFill>
+              </a:defRPr>
+            </a:pPr>
+            <a:r>
+              <a:t>• Multi-Tab Command Ledger: Seamless toggle between real-time incidents and patrol unit fleet statuses.</a:t>
             </a:r>
           </a:p>
         </p:txBody>
@@ -4630,13 +7032,13 @@
         <p:spPr>
           <a:xfrm>
             <a:off x="0" y="0"/>
-            <a:ext cx="12191695" cy="1097280"/>
+            <a:ext cx="12191695" cy="6858000"/>
           </a:xfrm>
           <a:prstGeom prst="rect">
             <a:avLst/>
           </a:prstGeom>
           <a:solidFill>
-            <a:srgbClr val="0F172A"/>
+            <a:srgbClr val="0A0F1E"/>
           </a:solidFill>
           <a:ln>
             <a:noFill/>
@@ -4672,8 +7074,8 @@
         </p:nvSpPr>
         <p:spPr>
           <a:xfrm>
-            <a:off x="731520" y="137160"/>
-            <a:ext cx="10698480" cy="822960"/>
+            <a:off x="731520" y="365760"/>
+            <a:ext cx="10728655" cy="1005840"/>
           </a:xfrm>
           <a:prstGeom prst="rect">
             <a:avLst/>
@@ -4687,40 +7089,226 @@
           <a:lstStyle/>
           <a:p>
             <a:pPr>
-              <a:defRPr sz="2400" b="1">
-                <a:solidFill>
-                  <a:srgbClr val="FFFFFF"/>
-                </a:solidFill>
-              </a:defRPr>
-            </a:pPr>
-            <a:r>
-              <a:t>7. Conclusion &amp; Future Roadmap</a:t>
-            </a:r>
-          </a:p>
-          <a:p>
-            <a:pPr>
-              <a:defRPr sz="1100">
-                <a:solidFill>
-                  <a:srgbClr val="94A3B8"/>
-                </a:solidFill>
-              </a:defRPr>
-            </a:pPr>
-            <a:r>
-              <a:t>Academic &amp; Industrial AI Project Series  |  Project 13 of 55</a:t>
-            </a:r>
-          </a:p>
-        </p:txBody>
-      </p:sp>
-      <p:sp>
-        <p:nvSpPr>
-          <p:cNvPr id="4" name="TextBox 3"/>
+              <a:defRPr sz="1100" b="1">
+                <a:solidFill>
+                  <a:srgbClr val="3B82F6"/>
+                </a:solidFill>
+              </a:defRPr>
+            </a:pPr>
+            <a:r>
+              <a:t>PUBLIC SAFETY AI &amp; PREDICTIVE LAW ENFORCEMENT</a:t>
+            </a:r>
+          </a:p>
+          <a:p>
+            <a:pPr>
+              <a:defRPr sz="2200" b="1">
+                <a:solidFill>
+                  <a:srgbClr val="F8FAFC"/>
+                </a:solidFill>
+              </a:defRPr>
+            </a:pPr>
+            <a:r>
+              <a:t>Spatial &amp; Temporal Parameter Simulation Workspace</a:t>
+            </a:r>
+          </a:p>
+        </p:txBody>
+      </p:sp>
+      <p:pic>
+        <p:nvPicPr>
+          <p:cNvPr id="4" name="Picture 3" descr="02_spatial_temporal_simulator.png"/>
+          <p:cNvPicPr>
+            <a:picLocks noChangeAspect="1"/>
+          </p:cNvPicPr>
+          <p:nvPr/>
+        </p:nvPicPr>
+        <p:blipFill>
+          <a:blip r:embed="rId2"/>
+          <a:stretch>
+            <a:fillRect/>
+          </a:stretch>
+        </p:blipFill>
+        <p:spPr>
+          <a:xfrm>
+            <a:off x="731520" y="1463040"/>
+            <a:ext cx="6858000" cy="4754880"/>
+          </a:xfrm>
+          <a:prstGeom prst="rect">
+            <a:avLst/>
+          </a:prstGeom>
+        </p:spPr>
+      </p:pic>
+      <p:sp>
+        <p:nvSpPr>
+          <p:cNvPr id="5" name="Rounded Rectangle 4"/>
+          <p:cNvSpPr/>
+          <p:nvPr/>
+        </p:nvSpPr>
+        <p:spPr>
+          <a:xfrm>
+            <a:off x="7863840" y="1463040"/>
+            <a:ext cx="3566160" cy="4754880"/>
+          </a:xfrm>
+          <a:prstGeom prst="roundRect">
+            <a:avLst/>
+          </a:prstGeom>
+          <a:solidFill>
+            <a:srgbClr val="141B2D"/>
+          </a:solidFill>
+          <a:ln>
+            <a:noFill/>
+          </a:ln>
+        </p:spPr>
+        <p:style>
+          <a:lnRef idx="1">
+            <a:schemeClr val="accent1"/>
+          </a:lnRef>
+          <a:fillRef idx="3">
+            <a:schemeClr val="accent1"/>
+          </a:fillRef>
+          <a:effectRef idx="2">
+            <a:schemeClr val="accent1"/>
+          </a:effectRef>
+          <a:fontRef idx="minor">
+            <a:schemeClr val="lt1"/>
+          </a:fontRef>
+        </p:style>
+        <p:txBody>
+          <a:bodyPr rtlCol="0" anchor="ctr" wrap="square"/>
+          <a:lstStyle/>
+          <a:p>
+            <a:pPr algn="ctr">
+              <a:defRPr b="1" sz="1700">
+                <a:solidFill>
+                  <a:srgbClr val="F59E0B"/>
+                </a:solidFill>
+              </a:defRPr>
+            </a:pPr>
+            <a:r>
+              <a:t>Simulation Workspace</a:t>
+            </a:r>
+          </a:p>
+          <a:p>
+            <a:br/>
+            <a:pPr>
+              <a:defRPr sz="1200">
+                <a:solidFill>
+                  <a:srgbClr val="F8FAFC"/>
+                </a:solidFill>
+              </a:defRPr>
+            </a:pPr>
+            <a:r>
+              <a:t>• Interactive Tactical Presets: 1-click simulation buttons for Late-Night Downtown, Transit Peak, Harbor Industrial, and Suburban Quiet.</a:t>
+            </a:r>
+          </a:p>
+          <a:p>
+            <a:pPr>
+              <a:defRPr sz="1200">
+                <a:solidFill>
+                  <a:srgbClr val="F8FAFC"/>
+                </a:solidFill>
+              </a:defRPr>
+            </a:pPr>
+            <a:r>
+              <a:t>• Fine-Grained Sliders: Dynamic 24-hour time-of-day slider, day of week selector, and ambient illumination controls.</a:t>
+            </a:r>
+          </a:p>
+          <a:p>
+            <a:pPr>
+              <a:defRPr sz="1200">
+                <a:solidFill>
+                  <a:srgbClr val="F8FAFC"/>
+                </a:solidFill>
+              </a:defRPr>
+            </a:pPr>
+            <a:r>
+              <a:t>• Environmental Multipliers: Adjustable historical crime density and officer patrol scores.</a:t>
+            </a:r>
+          </a:p>
+          <a:p>
+            <a:pPr>
+              <a:defRPr sz="1200">
+                <a:solidFill>
+                  <a:srgbClr val="F8FAFC"/>
+                </a:solidFill>
+              </a:defRPr>
+            </a:pPr>
+            <a:r>
+              <a:t>• Instant Validation: Executes forward inference in under 5 ms.</a:t>
+            </a:r>
+          </a:p>
+        </p:txBody>
+      </p:sp>
+    </p:spTree>
+  </p:cSld>
+  <p:clrMapOvr>
+    <a:masterClrMapping/>
+  </p:clrMapOvr>
+</p:sld>
+</file>
+
+<file path=ppt/slides/slide9.xml><?xml version="1.0" encoding="utf-8"?>
+<p:sld xmlns:a="http://schemas.openxmlformats.org/drawingml/2006/main" xmlns:p="http://schemas.openxmlformats.org/presentationml/2006/main" xmlns:r="http://schemas.openxmlformats.org/officeDocument/2006/relationships">
+  <p:cSld>
+    <p:spTree>
+      <p:nvGrpSpPr>
+        <p:cNvPr id="1" name=""/>
+        <p:cNvGrpSpPr/>
+        <p:nvPr/>
+      </p:nvGrpSpPr>
+      <p:grpSpPr/>
+      <p:sp>
+        <p:nvSpPr>
+          <p:cNvPr id="2" name="Rectangle 1"/>
+          <p:cNvSpPr/>
+          <p:nvPr/>
+        </p:nvSpPr>
+        <p:spPr>
+          <a:xfrm>
+            <a:off x="0" y="0"/>
+            <a:ext cx="12191695" cy="6858000"/>
+          </a:xfrm>
+          <a:prstGeom prst="rect">
+            <a:avLst/>
+          </a:prstGeom>
+          <a:solidFill>
+            <a:srgbClr val="0A0F1E"/>
+          </a:solidFill>
+          <a:ln>
+            <a:noFill/>
+          </a:ln>
+        </p:spPr>
+        <p:style>
+          <a:lnRef idx="1">
+            <a:schemeClr val="accent1"/>
+          </a:lnRef>
+          <a:fillRef idx="3">
+            <a:schemeClr val="accent1"/>
+          </a:fillRef>
+          <a:effectRef idx="2">
+            <a:schemeClr val="accent1"/>
+          </a:effectRef>
+          <a:fontRef idx="minor">
+            <a:schemeClr val="lt1"/>
+          </a:fontRef>
+        </p:style>
+        <p:txBody>
+          <a:bodyPr rtlCol="0" anchor="ctr"/>
+          <a:lstStyle/>
+          <a:p>
+            <a:pPr algn="ctr"/>
+          </a:p>
+        </p:txBody>
+      </p:sp>
+      <p:sp>
+        <p:nvSpPr>
+          <p:cNvPr id="3" name="TextBox 2"/>
           <p:cNvSpPr txBox="1"/>
           <p:nvPr/>
         </p:nvSpPr>
         <p:spPr>
           <a:xfrm>
-            <a:off x="731520" y="1371600"/>
-            <a:ext cx="10698480" cy="5029200"/>
+            <a:off x="731520" y="365760"/>
+            <a:ext cx="10728655" cy="1005840"/>
           </a:xfrm>
           <a:prstGeom prst="rect">
             <a:avLst/>
@@ -4734,83 +7322,177 @@
           <a:lstStyle/>
           <a:p>
             <a:pPr>
-              <a:spcBef>
-                <a:spcPts val="1000"/>
-              </a:spcBef>
-              <a:defRPr sz="1500" b="1">
-                <a:solidFill>
-                  <a:srgbClr val="0F172A"/>
-                </a:solidFill>
-              </a:defRPr>
-            </a:pPr>
-            <a:r>
-              <a:t>■ Project Accomplishments</a:t>
-            </a:r>
-          </a:p>
-          <a:p>
-            <a:pPr>
-              <a:defRPr sz="1300">
-                <a:solidFill>
-                  <a:srgbClr val="475569"/>
-                </a:solidFill>
-              </a:defRPr>
-            </a:pPr>
-            <a:r>
-              <a:t>Engineered a robust, end-to-end prototype validating the initial abstract with reproducible experiments.</a:t>
-            </a:r>
-          </a:p>
-          <a:p>
-            <a:pPr>
-              <a:spcBef>
-                <a:spcPts val="1000"/>
-              </a:spcBef>
-              <a:defRPr sz="1500" b="1">
-                <a:solidFill>
-                  <a:srgbClr val="0F172A"/>
-                </a:solidFill>
-              </a:defRPr>
-            </a:pPr>
-            <a:r>
-              <a:t>■ Industrial Significance</a:t>
-            </a:r>
-          </a:p>
-          <a:p>
-            <a:pPr>
-              <a:defRPr sz="1300">
-                <a:solidFill>
-                  <a:srgbClr val="475569"/>
-                </a:solidFill>
-              </a:defRPr>
-            </a:pPr>
-            <a:r>
-              <a:t>Eliminates latency and manual friction while ensuring high confidence automated decision support.</a:t>
-            </a:r>
-          </a:p>
-          <a:p>
-            <a:pPr>
-              <a:spcBef>
-                <a:spcPts val="1000"/>
-              </a:spcBef>
-              <a:defRPr sz="1500" b="1">
-                <a:solidFill>
-                  <a:srgbClr val="0F172A"/>
-                </a:solidFill>
-              </a:defRPr>
-            </a:pPr>
-            <a:r>
-              <a:t>■ Future Scope &amp; Extensions</a:t>
-            </a:r>
-          </a:p>
-          <a:p>
-            <a:pPr>
-              <a:defRPr sz="1300">
-                <a:solidFill>
-                  <a:srgbClr val="475569"/>
-                </a:solidFill>
-              </a:defRPr>
-            </a:pPr>
-            <a:r>
-              <a:t>Integration with federated edge sensors, distributed multi-tenant cloud clustering, and automated active learning.</a:t>
+              <a:defRPr sz="1100" b="1">
+                <a:solidFill>
+                  <a:srgbClr val="3B82F6"/>
+                </a:solidFill>
+              </a:defRPr>
+            </a:pPr>
+            <a:r>
+              <a:t>PUBLIC SAFETY AI &amp; PREDICTIVE LAW ENFORCEMENT</a:t>
+            </a:r>
+          </a:p>
+          <a:p>
+            <a:pPr>
+              <a:defRPr sz="2200" b="1">
+                <a:solidFill>
+                  <a:srgbClr val="F8FAFC"/>
+                </a:solidFill>
+              </a:defRPr>
+            </a:pPr>
+            <a:r>
+              <a:t>Critical Threat Incident Prediction &amp; Automated Dispatch</a:t>
+            </a:r>
+          </a:p>
+        </p:txBody>
+      </p:sp>
+      <p:pic>
+        <p:nvPicPr>
+          <p:cNvPr id="4" name="Picture 3" descr="03_critical_threat_prediction.png"/>
+          <p:cNvPicPr>
+            <a:picLocks noChangeAspect="1"/>
+          </p:cNvPicPr>
+          <p:nvPr/>
+        </p:nvPicPr>
+        <p:blipFill>
+          <a:blip r:embed="rId2"/>
+          <a:stretch>
+            <a:fillRect/>
+          </a:stretch>
+        </p:blipFill>
+        <p:spPr>
+          <a:xfrm>
+            <a:off x="731520" y="1463040"/>
+            <a:ext cx="6858000" cy="4754880"/>
+          </a:xfrm>
+          <a:prstGeom prst="rect">
+            <a:avLst/>
+          </a:prstGeom>
+        </p:spPr>
+      </p:pic>
+      <p:sp>
+        <p:nvSpPr>
+          <p:cNvPr id="5" name="Rounded Rectangle 4"/>
+          <p:cNvSpPr/>
+          <p:nvPr/>
+        </p:nvSpPr>
+        <p:spPr>
+          <a:xfrm>
+            <a:off x="7863840" y="1463040"/>
+            <a:ext cx="3566160" cy="4754880"/>
+          </a:xfrm>
+          <a:prstGeom prst="roundRect">
+            <a:avLst/>
+          </a:prstGeom>
+          <a:solidFill>
+            <a:srgbClr val="141B2D"/>
+          </a:solidFill>
+          <a:ln w="19050">
+            <a:solidFill>
+              <a:srgbClr val="EF4444"/>
+            </a:solidFill>
+          </a:ln>
+        </p:spPr>
+        <p:style>
+          <a:lnRef idx="1">
+            <a:schemeClr val="accent1"/>
+          </a:lnRef>
+          <a:fillRef idx="3">
+            <a:schemeClr val="accent1"/>
+          </a:fillRef>
+          <a:effectRef idx="2">
+            <a:schemeClr val="accent1"/>
+          </a:effectRef>
+          <a:fontRef idx="minor">
+            <a:schemeClr val="lt1"/>
+          </a:fontRef>
+        </p:style>
+        <p:txBody>
+          <a:bodyPr rtlCol="0" anchor="ctr" wrap="square"/>
+          <a:lstStyle/>
+          <a:p>
+            <a:pPr algn="ctr">
+              <a:defRPr b="1" sz="1700">
+                <a:solidFill>
+                  <a:srgbClr val="EF4444"/>
+                </a:solidFill>
+              </a:defRPr>
+            </a:pPr>
+            <a:r>
+              <a:t>Critical Scenario Evidence</a:t>
+            </a:r>
+          </a:p>
+          <a:p>
+            <a:br/>
+            <a:pPr>
+              <a:defRPr sz="1200">
+                <a:solidFill>
+                  <a:srgbClr val="F8FAFC"/>
+                </a:solidFill>
+              </a:defRPr>
+            </a:pPr>
+            <a:r>
+              <a:t>• Predicted Threat Level: CRITICAL</a:t>
+            </a:r>
+          </a:p>
+          <a:p>
+            <a:pPr>
+              <a:defRPr sz="1200">
+                <a:solidFill>
+                  <a:srgbClr val="F8FAFC"/>
+                </a:solidFill>
+              </a:defRPr>
+            </a:pPr>
+            <a:r>
+              <a:t>• Neural Confidence: 88.4%</a:t>
+            </a:r>
+          </a:p>
+          <a:p>
+            <a:pPr>
+              <a:defRPr sz="1200">
+                <a:solidFill>
+                  <a:srgbClr val="F8FAFC"/>
+                </a:solidFill>
+              </a:defRPr>
+            </a:pPr>
+            <a:r>
+              <a:t>• Predicted Offense: ROBBERY</a:t>
+            </a:r>
+          </a:p>
+          <a:p>
+            <a:pPr>
+              <a:defRPr sz="1200">
+                <a:solidFill>
+                  <a:srgbClr val="F8FAFC"/>
+                </a:solidFill>
+              </a:defRPr>
+            </a:pPr>
+            <a:r>
+              <a:t>• Probability Breakdown: Critical 62.5%, High 25.0%, Mod 10.0%, Low 2.5%</a:t>
+            </a:r>
+          </a:p>
+          <a:p>
+            <a:pPr>
+              <a:defRPr sz="1200">
+                <a:solidFill>
+                  <a:srgbClr val="F8FAFC"/>
+                </a:solidFill>
+              </a:defRPr>
+            </a:pPr>
+            <a:r>
+              <a:t>• Tactical Action: URGENT - CODE 3: Dispatch Immediate High-Visibility Tactical Patrol Unit</a:t>
+            </a:r>
+          </a:p>
+          <a:p>
+            <a:pPr>
+              <a:defRPr sz="1200">
+                <a:solidFill>
+                  <a:srgbClr val="F8FAFC"/>
+                </a:solidFill>
+              </a:defRPr>
+            </a:pPr>
+            <a:r>
+              <a:t>• Automated Fleet Dispatch: TRIGGERED</a:t>
             </a:r>
           </a:p>
         </p:txBody>

</xml_diff>